<commit_message>
feature: create modern clean presentation
</commit_message>
<xml_diff>
--- a/PRESENTATION.pptx
+++ b/PRESENTATION.pptx
@@ -11,9 +11,10 @@
     <p:sldId id="259" r:id="rId5"/>
     <p:sldId id="260" r:id="rId6"/>
     <p:sldId id="261" r:id="rId7"/>
+    <p:sldId id="262" r:id="rId8"/>
   </p:sldIdLst>
   <p:notesMasterIdLst>
-    <p:notesMasterId r:id="rId8"/>
+    <p:notesMasterId r:id="rId9"/>
   </p:notesMasterIdLst>
   <p:sldSz cx="9144000" cy="5143500"/>
   <p:notesSz cx="5143500" cy="9144000"/>
@@ -971,6 +972,94 @@
             <a:fld id="{F7021451-1387-4CA6-816F-3879F97B5CBC}" type="slidenum">
               <a:rPr lang="en-US"/>
               <a:t>6</a:t>
+            </a:fld>
+            <a:endParaRPr lang="en-US"/>
+          </a:p>
+        </p:txBody>
+      </p:sp>
+    </p:spTree>
+    <p:extLst>
+      <p:ext uri="{BB962C8B-B14F-4D97-AF65-F5344CB8AC3E}">
+        <p14:creationId xmlns:p14="http://schemas.microsoft.com/office/powerpoint/2010/main" val="1024086991"/>
+      </p:ext>
+    </p:extLst>
+  </p:cSld>
+  <p:clrMapOvr>
+    <a:masterClrMapping/>
+  </p:clrMapOvr>
+</p:notes>
+</file>
+
+<file path=ppt/notesSlides/notesSlide7.xml><?xml version="1.0" encoding="utf-8"?>
+<p:notes xmlns:a="http://schemas.openxmlformats.org/drawingml/2006/main" xmlns:r="http://schemas.openxmlformats.org/officeDocument/2006/relationships" xmlns:p="http://schemas.openxmlformats.org/presentationml/2006/main">
+  <p:cSld>
+    <p:spTree>
+      <p:nvGrpSpPr>
+        <p:cNvPr id="1" name=""/>
+        <p:cNvGrpSpPr/>
+        <p:nvPr/>
+      </p:nvGrpSpPr>
+      <p:grpSpPr>
+        <a:xfrm>
+          <a:off x="0" y="0"/>
+          <a:ext cx="0" cy="0"/>
+          <a:chOff x="0" y="0"/>
+          <a:chExt cx="0" cy="0"/>
+        </a:xfrm>
+      </p:grpSpPr>
+      <p:sp>
+        <p:nvSpPr>
+          <p:cNvPr id="2" name="Slide Image Placeholder 1"/>
+          <p:cNvSpPr>
+            <a:spLocks noGrp="1" noRot="1" noChangeAspect="1"/>
+          </p:cNvSpPr>
+          <p:nvPr>
+            <p:ph type="sldImg"/>
+          </p:nvPr>
+        </p:nvSpPr>
+        <p:spPr/>
+      </p:sp>
+      <p:sp>
+        <p:nvSpPr>
+          <p:cNvPr id="3" name="Notes Placeholder 2"/>
+          <p:cNvSpPr>
+            <a:spLocks noGrp="1"/>
+          </p:cNvSpPr>
+          <p:nvPr>
+            <p:ph type="body" idx="1"/>
+          </p:nvPr>
+        </p:nvSpPr>
+        <p:spPr/>
+        <p:txBody>
+          <a:bodyPr/>
+          <a:lstStyle/>
+          <a:p>
+            <a:r>
+              <a:rPr lang="en-US" dirty="0"/>
+              <a:t/>
+            </a:r>
+            <a:endParaRPr lang="en-US" dirty="0"/>
+          </a:p>
+        </p:txBody>
+      </p:sp>
+      <p:sp>
+        <p:nvSpPr>
+          <p:cNvPr id="4" name="Slide Number Placeholder 3"/>
+          <p:cNvSpPr>
+            <a:spLocks noGrp="1"/>
+          </p:cNvSpPr>
+          <p:nvPr>
+            <p:ph type="sldNum" sz="quarter" idx="10"/>
+          </p:nvPr>
+        </p:nvSpPr>
+        <p:spPr/>
+        <p:txBody>
+          <a:bodyPr/>
+          <a:lstStyle/>
+          <a:p>
+            <a:fld id="{F7021451-1387-4CA6-816F-3879F97B5CBC}" type="slidenum">
+              <a:rPr lang="en-US"/>
+              <a:t>7</a:t>
             </a:fld>
             <a:endParaRPr lang="en-US"/>
           </a:p>
@@ -1302,7 +1391,7 @@
     <p:bg>
       <p:bgPr>
         <a:solidFill>
-          <a:srgbClr val="1E293B"/>
+          <a:srgbClr val="0F172A"/>
         </a:solidFill>
       </p:bgPr>
     </p:bg>
@@ -1328,8 +1417,8 @@
         </p:nvSpPr>
         <p:spPr>
           <a:xfrm>
-            <a:off x="914400" y="2011680"/>
-            <a:ext cx="10332720" cy="914400"/>
+            <a:off x="457200" y="1463040"/>
+            <a:ext cx="8229600" cy="731520"/>
           </a:xfrm>
           <a:prstGeom prst="rect">
             <a:avLst/>
@@ -1341,34 +1430,54 @@
           <a:bodyPr wrap="square" rtlCol="0" anchor="ctr"/>
           <a:lstStyle/>
           <a:p>
-            <a:pPr indent="0" marL="0">
-              <a:buNone/>
-            </a:pPr>
-            <a:r>
-              <a:rPr lang="en-US" sz="4400" b="1" dirty="0">
-                <a:solidFill>
-                  <a:srgbClr val="14B8A6"/>
-                </a:solidFill>
-                <a:latin typeface="Arial" pitchFamily="34" charset="0"/>
-                <a:ea typeface="Arial" pitchFamily="34" charset="-122"/>
-                <a:cs typeface="Arial" pitchFamily="34" charset="-120"/>
+            <a:pPr algn="ctr" indent="0" marL="0">
+              <a:buNone/>
+            </a:pPr>
+            <a:r>
+              <a:rPr lang="en-US" sz="3200" b="1" dirty="0">
+                <a:solidFill>
+                  <a:srgbClr val="F8FAFC"/>
+                </a:solidFill>
+                <a:latin typeface="Segoe UI" pitchFamily="34" charset="0"/>
+                <a:ea typeface="Segoe UI" pitchFamily="34" charset="-122"/>
+                <a:cs typeface="Segoe UI" pitchFamily="34" charset="-120"/>
               </a:rPr>
               <a:t>School Management System</a:t>
             </a:r>
-            <a:endParaRPr lang="en-US" sz="4400" dirty="0"/>
-          </a:p>
-        </p:txBody>
-      </p:sp>
-      <p:sp>
-        <p:nvSpPr>
-          <p:cNvPr id="3" name="Text 1"/>
-          <p:cNvSpPr/>
-          <p:nvPr/>
-        </p:nvSpPr>
-        <p:spPr>
-          <a:xfrm>
-            <a:off x="914400" y="2926080"/>
-            <a:ext cx="10332720" cy="731520"/>
+            <a:endParaRPr lang="en-US" sz="3200" dirty="0"/>
+          </a:p>
+        </p:txBody>
+      </p:sp>
+      <p:sp>
+        <p:nvSpPr>
+          <p:cNvPr id="3" name="Shape 1"/>
+          <p:cNvSpPr/>
+          <p:nvPr/>
+        </p:nvSpPr>
+        <p:spPr>
+          <a:xfrm>
+            <a:off x="3200400" y="2286000"/>
+            <a:ext cx="2743200" cy="36576"/>
+          </a:xfrm>
+          <a:prstGeom prst="rect">
+            <a:avLst/>
+          </a:prstGeom>
+          <a:solidFill>
+            <a:srgbClr val="10B981"/>
+          </a:solidFill>
+          <a:ln/>
+        </p:spPr>
+      </p:sp>
+      <p:sp>
+        <p:nvSpPr>
+          <p:cNvPr id="4" name="Text 2"/>
+          <p:cNvSpPr/>
+          <p:nvPr/>
+        </p:nvSpPr>
+        <p:spPr>
+          <a:xfrm>
+            <a:off x="457200" y="2560320"/>
+            <a:ext cx="8229600" cy="457200"/>
           </a:xfrm>
           <a:prstGeom prst="rect">
             <a:avLst/>
@@ -1380,34 +1489,34 @@
           <a:bodyPr wrap="square" rtlCol="0" anchor="ctr"/>
           <a:lstStyle/>
           <a:p>
-            <a:pPr indent="0" marL="0">
-              <a:buNone/>
-            </a:pPr>
-            <a:r>
-              <a:rPr lang="en-US" sz="2400" dirty="0">
-                <a:solidFill>
-                  <a:srgbClr val="FFFFFF"/>
-                </a:solidFill>
-                <a:latin typeface="Arial" pitchFamily="34" charset="0"/>
-                <a:ea typeface="Arial" pitchFamily="34" charset="-122"/>
-                <a:cs typeface="Arial" pitchFamily="34" charset="-120"/>
-              </a:rPr>
-              <a:t>Test-Setup &amp; Qualitätssicherungs-Konzept</a:t>
-            </a:r>
-            <a:endParaRPr lang="en-US" sz="2400" dirty="0"/>
-          </a:p>
-        </p:txBody>
-      </p:sp>
-      <p:sp>
-        <p:nvSpPr>
-          <p:cNvPr id="4" name="Text 2"/>
-          <p:cNvSpPr/>
-          <p:nvPr/>
-        </p:nvSpPr>
-        <p:spPr>
-          <a:xfrm>
-            <a:off x="914400" y="4114800"/>
-            <a:ext cx="10332720" cy="914400"/>
+            <a:pPr algn="ctr" indent="0" marL="0">
+              <a:buNone/>
+            </a:pPr>
+            <a:r>
+              <a:rPr lang="en-US" sz="1600" dirty="0">
+                <a:solidFill>
+                  <a:srgbClr val="3B82F6"/>
+                </a:solidFill>
+                <a:latin typeface="Segoe UI" pitchFamily="34" charset="0"/>
+                <a:ea typeface="Segoe UI" pitchFamily="34" charset="-122"/>
+                <a:cs typeface="Segoe UI" pitchFamily="34" charset="-120"/>
+              </a:rPr>
+              <a:t>Projektarbeit – Testdokumentation &amp; Setup</a:t>
+            </a:r>
+            <a:endParaRPr lang="en-US" sz="1600" dirty="0"/>
+          </a:p>
+        </p:txBody>
+      </p:sp>
+      <p:sp>
+        <p:nvSpPr>
+          <p:cNvPr id="5" name="Text 3"/>
+          <p:cNvSpPr/>
+          <p:nvPr/>
+        </p:nvSpPr>
+        <p:spPr>
+          <a:xfrm>
+            <a:off x="457200" y="3840480"/>
+            <a:ext cx="8229600" cy="548640"/>
           </a:xfrm>
           <a:prstGeom prst="rect">
             <a:avLst/>
@@ -1419,38 +1528,44 @@
           <a:bodyPr wrap="square" rtlCol="0" anchor="ctr"/>
           <a:lstStyle/>
           <a:p>
-            <a:pPr indent="0" marL="0">
-              <a:buNone/>
-            </a:pPr>
-            <a:r>
-              <a:rPr lang="en-US" sz="1600" dirty="0">
-                <a:solidFill>
-                  <a:srgbClr val="94A3B8"/>
-                </a:solidFill>
-                <a:latin typeface="Arial" pitchFamily="34" charset="0"/>
-                <a:ea typeface="Arial" pitchFamily="34" charset="-122"/>
-                <a:cs typeface="Arial" pitchFamily="34" charset="-120"/>
-              </a:rPr>
-              <a:t>Projektpräsentation | 25.06.2026</a:t>
-            </a:r>
-            <a:endParaRPr lang="en-US" sz="1600" dirty="0"/>
-          </a:p>
-          <a:p>
-            <a:pPr indent="0" marL="0">
-              <a:buNone/>
-            </a:pPr>
-            <a:r>
-              <a:rPr lang="en-US" sz="1600" dirty="0">
-                <a:solidFill>
-                  <a:srgbClr val="94A3B8"/>
-                </a:solidFill>
-                <a:latin typeface="Arial" pitchFamily="34" charset="0"/>
-                <a:ea typeface="Arial" pitchFamily="34" charset="-122"/>
-                <a:cs typeface="Arial" pitchFamily="34" charset="-120"/>
-              </a:rPr>
-              <a:t>Erstellt von: Aldin Memic &amp; Ljundrim Ganiji</a:t>
-            </a:r>
-            <a:endParaRPr lang="en-US" sz="1600" dirty="0"/>
+            <a:pPr algn="ctr" indent="0" marL="0">
+              <a:lnSpc>
+                <a:spcPts val="1600"/>
+              </a:lnSpc>
+              <a:buNone/>
+            </a:pPr>
+            <a:r>
+              <a:rPr lang="en-US" sz="1200" dirty="0">
+                <a:solidFill>
+                  <a:srgbClr val="64748B"/>
+                </a:solidFill>
+                <a:latin typeface="Segoe UI" pitchFamily="34" charset="0"/>
+                <a:ea typeface="Segoe UI" pitchFamily="34" charset="-122"/>
+                <a:cs typeface="Segoe UI" pitchFamily="34" charset="-120"/>
+              </a:rPr>
+              <a:t>Vorgelegt von:</a:t>
+            </a:r>
+            <a:endParaRPr lang="en-US" sz="1200" dirty="0"/>
+          </a:p>
+          <a:p>
+            <a:pPr algn="ctr" indent="0" marL="0">
+              <a:lnSpc>
+                <a:spcPts val="1600"/>
+              </a:lnSpc>
+              <a:buNone/>
+            </a:pPr>
+            <a:r>
+              <a:rPr lang="en-US" sz="1200" dirty="0">
+                <a:solidFill>
+                  <a:srgbClr val="64748B"/>
+                </a:solidFill>
+                <a:latin typeface="Segoe UI" pitchFamily="34" charset="0"/>
+                <a:ea typeface="Segoe UI" pitchFamily="34" charset="-122"/>
+                <a:cs typeface="Segoe UI" pitchFamily="34" charset="-120"/>
+              </a:rPr>
+              <a:t>Aldin Memic &amp; Ljundrim Ganiji</a:t>
+            </a:r>
+            <a:endParaRPr lang="en-US" sz="1200" dirty="0"/>
           </a:p>
         </p:txBody>
       </p:sp>
@@ -1468,7 +1583,7 @@
     <p:bg>
       <p:bgPr>
         <a:solidFill>
-          <a:srgbClr val="1E293B"/>
+          <a:srgbClr val="F8FAFC"/>
         </a:solidFill>
       </p:bgPr>
     </p:bg>
@@ -1494,8 +1609,8 @@
         </p:nvSpPr>
         <p:spPr>
           <a:xfrm>
-            <a:off x="914400" y="548640"/>
-            <a:ext cx="10332720" cy="914400"/>
+            <a:off x="731520" y="365760"/>
+            <a:ext cx="7680960" cy="365760"/>
           </a:xfrm>
           <a:prstGeom prst="rect">
             <a:avLst/>
@@ -1511,30 +1626,75 @@
               <a:buNone/>
             </a:pPr>
             <a:r>
-              <a:rPr lang="en-US" sz="3200" b="1" dirty="0">
-                <a:solidFill>
-                  <a:srgbClr val="14B8A6"/>
-                </a:solidFill>
-                <a:latin typeface="Arial" pitchFamily="34" charset="0"/>
-                <a:ea typeface="Arial" pitchFamily="34" charset="-122"/>
-                <a:cs typeface="Arial" pitchFamily="34" charset="-120"/>
-              </a:rPr>
-              <a:t>Webanwendung &amp; Testpyramide</a:t>
-            </a:r>
-            <a:endParaRPr lang="en-US" sz="3200" dirty="0"/>
-          </a:p>
-        </p:txBody>
-      </p:sp>
-      <p:sp>
-        <p:nvSpPr>
-          <p:cNvPr id="3" name="Text 1"/>
-          <p:cNvSpPr/>
-          <p:nvPr/>
-        </p:nvSpPr>
-        <p:spPr>
-          <a:xfrm>
-            <a:off x="914400" y="1645920"/>
-            <a:ext cx="10332720" cy="4572000"/>
+              <a:rPr lang="en-US" sz="2000" b="1" dirty="0">
+                <a:solidFill>
+                  <a:srgbClr val="1E293B"/>
+                </a:solidFill>
+                <a:latin typeface="Segoe UI" pitchFamily="34" charset="0"/>
+                <a:ea typeface="Segoe UI" pitchFamily="34" charset="-122"/>
+                <a:cs typeface="Segoe UI" pitchFamily="34" charset="-120"/>
+              </a:rPr>
+              <a:t>System-Architektur &amp; Tech-Stack</a:t>
+            </a:r>
+            <a:endParaRPr lang="en-US" sz="2000" dirty="0"/>
+          </a:p>
+        </p:txBody>
+      </p:sp>
+      <p:sp>
+        <p:nvSpPr>
+          <p:cNvPr id="3" name="Shape 1"/>
+          <p:cNvSpPr/>
+          <p:nvPr/>
+        </p:nvSpPr>
+        <p:spPr>
+          <a:xfrm>
+            <a:off x="731520" y="822960"/>
+            <a:ext cx="7680960" cy="18288"/>
+          </a:xfrm>
+          <a:prstGeom prst="rect">
+            <a:avLst/>
+          </a:prstGeom>
+          <a:solidFill>
+            <a:srgbClr val="3B82F6"/>
+          </a:solidFill>
+          <a:ln/>
+        </p:spPr>
+      </p:sp>
+      <p:sp>
+        <p:nvSpPr>
+          <p:cNvPr id="4" name="Shape 2"/>
+          <p:cNvSpPr/>
+          <p:nvPr/>
+        </p:nvSpPr>
+        <p:spPr>
+          <a:xfrm>
+            <a:off x="731520" y="1097280"/>
+            <a:ext cx="3657600" cy="3474720"/>
+          </a:xfrm>
+          <a:prstGeom prst="rect">
+            <a:avLst/>
+          </a:prstGeom>
+          <a:solidFill>
+            <a:srgbClr val="FFFFFF"/>
+          </a:solidFill>
+          <a:ln w="12700">
+            <a:solidFill>
+              <a:srgbClr val="E2E8F0"/>
+            </a:solidFill>
+            <a:prstDash val="solid"/>
+          </a:ln>
+        </p:spPr>
+      </p:sp>
+      <p:sp>
+        <p:nvSpPr>
+          <p:cNvPr id="5" name="Text 3"/>
+          <p:cNvSpPr/>
+          <p:nvPr/>
+        </p:nvSpPr>
+        <p:spPr>
+          <a:xfrm>
+            <a:off x="914400" y="1280160"/>
+            <a:ext cx="3291840" cy="274320"/>
           </a:xfrm>
           <a:prstGeom prst="rect">
             <a:avLst/>
@@ -1550,99 +1710,333 @@
               <a:buNone/>
             </a:pPr>
             <a:r>
-              <a:rPr lang="en-US" sz="2200" b="1" dirty="0">
-                <a:solidFill>
-                  <a:srgbClr val="14B8A6"/>
-                </a:solidFill>
-              </a:rPr>
-              <a:t>Das System: School Management System
+              <a:rPr lang="en-US" sz="1400" b="1" dirty="0">
+                <a:solidFill>
+                  <a:srgbClr val="1E3A8A"/>
+                </a:solidFill>
+                <a:latin typeface="Segoe UI" pitchFamily="34" charset="0"/>
+                <a:ea typeface="Segoe UI" pitchFamily="34" charset="-122"/>
+                <a:cs typeface="Segoe UI" pitchFamily="34" charset="-120"/>
+              </a:rPr>
+              <a:t>Frontend-Architektur</a:t>
+            </a:r>
+            <a:endParaRPr lang="en-US" sz="1400" dirty="0"/>
+          </a:p>
+        </p:txBody>
+      </p:sp>
+      <p:sp>
+        <p:nvSpPr>
+          <p:cNvPr id="6" name="Text 4"/>
+          <p:cNvSpPr/>
+          <p:nvPr/>
+        </p:nvSpPr>
+        <p:spPr>
+          <a:xfrm>
+            <a:off x="914400" y="1645920"/>
+            <a:ext cx="3291840" cy="2743200"/>
+          </a:xfrm>
+          <a:prstGeom prst="rect">
+            <a:avLst/>
+          </a:prstGeom>
+          <a:noFill/>
+          <a:ln/>
+        </p:spPr>
+        <p:txBody>
+          <a:bodyPr wrap="square" rtlCol="0" anchor="ctr"/>
+          <a:lstStyle/>
+          <a:p>
+            <a:pPr indent="0" marL="0">
+              <a:lnSpc>
+                <a:spcPts val="1500"/>
+              </a:lnSpc>
+              <a:spcAft>
+                <a:spcPts val="800"/>
+              </a:spcAft>
+              <a:buNone/>
+            </a:pPr>
+            <a:r>
+              <a:rPr lang="en-US" sz="1050" dirty="0">
+                <a:solidFill>
+                  <a:srgbClr val="1E293B"/>
+                </a:solidFill>
+                <a:latin typeface="Segoe UI" pitchFamily="34" charset="0"/>
+                <a:ea typeface="Segoe UI" pitchFamily="34" charset="-122"/>
+                <a:cs typeface="Segoe UI" pitchFamily="34" charset="-120"/>
+              </a:rPr>
+              <a:t>• Angular 17 SPA (sakai-ng Dashboard-Template)
 </a:t>
             </a:r>
             <a:pPr indent="0" marL="0">
-              <a:buNone/>
-            </a:pPr>
-            <a:r>
-              <a:rPr lang="en-US" sz="1600" dirty="0">
-                <a:solidFill>
-                  <a:srgbClr val="FFFFFF"/>
-                </a:solidFill>
-              </a:rPr>
-              <a:t>• Frontend: Angular 17 SPA mit PrimeNG Components.
+              <a:lnSpc>
+                <a:spcPts val="1500"/>
+              </a:lnSpc>
+              <a:spcAft>
+                <a:spcPts val="800"/>
+              </a:spcAft>
+              <a:buNone/>
+            </a:pPr>
+            <a:r>
+              <a:rPr lang="en-US" sz="1050" dirty="0">
+                <a:solidFill>
+                  <a:srgbClr val="1E293B"/>
+                </a:solidFill>
+                <a:latin typeface="Segoe UI" pitchFamily="34" charset="0"/>
+                <a:ea typeface="Segoe UI" pitchFamily="34" charset="-122"/>
+                <a:cs typeface="Segoe UI" pitchFamily="34" charset="-120"/>
+              </a:rPr>
+              <a:t>• PrimeNG 17 &amp; PrimeFlex UI-Komponenten
 </a:t>
             </a:r>
             <a:pPr indent="0" marL="0">
-              <a:buNone/>
-            </a:pPr>
-            <a:r>
-              <a:rPr lang="en-US" sz="1600" dirty="0">
-                <a:solidFill>
-                  <a:srgbClr val="FFFFFF"/>
-                </a:solidFill>
-              </a:rPr>
-              <a:t>• Backend: ASP.NET Core v8.0 Web-API.
+              <a:lnSpc>
+                <a:spcPts val="1500"/>
+              </a:lnSpc>
+              <a:spcAft>
+                <a:spcPts val="800"/>
+              </a:spcAft>
+              <a:buNone/>
+            </a:pPr>
+            <a:r>
+              <a:rPr lang="en-US" sz="1050" dirty="0">
+                <a:solidFill>
+                  <a:srgbClr val="1E293B"/>
+                </a:solidFill>
+                <a:latin typeface="Segoe UI" pitchFamily="34" charset="0"/>
+                <a:ea typeface="Segoe UI" pitchFamily="34" charset="-122"/>
+                <a:cs typeface="Segoe UI" pitchFamily="34" charset="-120"/>
+              </a:rPr>
+              <a:t>• RxJS für reaktive Datenströme &amp; HTTP-Requests
 </a:t>
             </a:r>
             <a:pPr indent="0" marL="0">
-              <a:buNone/>
-            </a:pPr>
-            <a:r>
-              <a:rPr lang="en-US" sz="2200" b="1" dirty="0">
-                <a:solidFill>
-                  <a:srgbClr val="F97316"/>
-                </a:solidFill>
-              </a:rPr>
-              <a:t>Soll-Mengengerüst (11 Tests pro Person | 22 Gesamt)
+              <a:lnSpc>
+                <a:spcPts val="1500"/>
+              </a:lnSpc>
+              <a:spcAft>
+                <a:spcPts val="800"/>
+              </a:spcAft>
+              <a:buNone/>
+            </a:pPr>
+            <a:r>
+              <a:rPr lang="en-US" sz="1050" dirty="0">
+                <a:solidFill>
+                  <a:srgbClr val="1E293B"/>
+                </a:solidFill>
+                <a:latin typeface="Segoe UI" pitchFamily="34" charset="0"/>
+                <a:ea typeface="Segoe UI" pitchFamily="34" charset="-122"/>
+                <a:cs typeface="Segoe UI" pitchFamily="34" charset="-120"/>
+              </a:rPr>
+              <a:t>• Jest für performante Unit- &amp; Integrationstests
 </a:t>
             </a:r>
             <a:pPr indent="0" marL="0">
-              <a:buNone/>
-            </a:pPr>
-            <a:r>
-              <a:rPr lang="en-US" sz="1600" dirty="0">
-                <a:solidFill>
-                  <a:srgbClr val="FFFFFF"/>
-                </a:solidFill>
-              </a:rPr>
-              <a:t>• 10 Unit Tests (5 pro Person): Einzeltest von Services in Jest.
+              <a:lnSpc>
+                <a:spcPts val="1500"/>
+              </a:lnSpc>
+              <a:buNone/>
+            </a:pPr>
+            <a:r>
+              <a:rPr lang="en-US" sz="1050" dirty="0">
+                <a:solidFill>
+                  <a:srgbClr val="1E293B"/>
+                </a:solidFill>
+                <a:latin typeface="Segoe UI" pitchFamily="34" charset="0"/>
+                <a:ea typeface="Segoe UI" pitchFamily="34" charset="-122"/>
+                <a:cs typeface="Segoe UI" pitchFamily="34" charset="-120"/>
+              </a:rPr>
+              <a:t>• Playwright für automatisierte E2E-Browsertests</a:t>
+            </a:r>
+            <a:endParaRPr lang="en-US" sz="1050" dirty="0"/>
+          </a:p>
+        </p:txBody>
+      </p:sp>
+      <p:sp>
+        <p:nvSpPr>
+          <p:cNvPr id="7" name="Shape 5"/>
+          <p:cNvSpPr/>
+          <p:nvPr/>
+        </p:nvSpPr>
+        <p:spPr>
+          <a:xfrm>
+            <a:off x="4754880" y="1097280"/>
+            <a:ext cx="3657600" cy="3474720"/>
+          </a:xfrm>
+          <a:prstGeom prst="rect">
+            <a:avLst/>
+          </a:prstGeom>
+          <a:solidFill>
+            <a:srgbClr val="FFFFFF"/>
+          </a:solidFill>
+          <a:ln w="12700">
+            <a:solidFill>
+              <a:srgbClr val="E2E8F0"/>
+            </a:solidFill>
+            <a:prstDash val="solid"/>
+          </a:ln>
+        </p:spPr>
+      </p:sp>
+      <p:sp>
+        <p:nvSpPr>
+          <p:cNvPr id="8" name="Text 6"/>
+          <p:cNvSpPr/>
+          <p:nvPr/>
+        </p:nvSpPr>
+        <p:spPr>
+          <a:xfrm>
+            <a:off x="4937760" y="1280160"/>
+            <a:ext cx="3291840" cy="274320"/>
+          </a:xfrm>
+          <a:prstGeom prst="rect">
+            <a:avLst/>
+          </a:prstGeom>
+          <a:noFill/>
+          <a:ln/>
+        </p:spPr>
+        <p:txBody>
+          <a:bodyPr wrap="square" rtlCol="0" anchor="ctr"/>
+          <a:lstStyle/>
+          <a:p>
+            <a:pPr indent="0" marL="0">
+              <a:buNone/>
+            </a:pPr>
+            <a:r>
+              <a:rPr lang="en-US" sz="1400" b="1" dirty="0">
+                <a:solidFill>
+                  <a:srgbClr val="1E3A8A"/>
+                </a:solidFill>
+                <a:latin typeface="Segoe UI" pitchFamily="34" charset="0"/>
+                <a:ea typeface="Segoe UI" pitchFamily="34" charset="-122"/>
+                <a:cs typeface="Segoe UI" pitchFamily="34" charset="-120"/>
+              </a:rPr>
+              <a:t>Backend &amp; Datenbank</a:t>
+            </a:r>
+            <a:endParaRPr lang="en-US" sz="1400" dirty="0"/>
+          </a:p>
+        </p:txBody>
+      </p:sp>
+      <p:sp>
+        <p:nvSpPr>
+          <p:cNvPr id="9" name="Text 7"/>
+          <p:cNvSpPr/>
+          <p:nvPr/>
+        </p:nvSpPr>
+        <p:spPr>
+          <a:xfrm>
+            <a:off x="4937760" y="1645920"/>
+            <a:ext cx="3291840" cy="2743200"/>
+          </a:xfrm>
+          <a:prstGeom prst="rect">
+            <a:avLst/>
+          </a:prstGeom>
+          <a:noFill/>
+          <a:ln/>
+        </p:spPr>
+        <p:txBody>
+          <a:bodyPr wrap="square" rtlCol="0" anchor="ctr"/>
+          <a:lstStyle/>
+          <a:p>
+            <a:pPr indent="0" marL="0">
+              <a:lnSpc>
+                <a:spcPts val="1500"/>
+              </a:lnSpc>
+              <a:spcAft>
+                <a:spcPts val="800"/>
+              </a:spcAft>
+              <a:buNone/>
+            </a:pPr>
+            <a:r>
+              <a:rPr lang="en-US" sz="1050" dirty="0">
+                <a:solidFill>
+                  <a:srgbClr val="1E293B"/>
+                </a:solidFill>
+                <a:latin typeface="Segoe UI" pitchFamily="34" charset="0"/>
+                <a:ea typeface="Segoe UI" pitchFamily="34" charset="-122"/>
+                <a:cs typeface="Segoe UI" pitchFamily="34" charset="-120"/>
+              </a:rPr>
+              <a:t>• ASP.NET Core 8.0 Web-API (REST-Schnittstellen)
 </a:t>
             </a:r>
             <a:pPr indent="0" marL="0">
-              <a:buNone/>
-            </a:pPr>
-            <a:r>
-              <a:rPr lang="en-US" sz="1600" dirty="0">
-                <a:solidFill>
-                  <a:srgbClr val="FFFFFF"/>
-                </a:solidFill>
-              </a:rPr>
-              <a:t>• 6 Integration Tests (3 pro Person): Komponententests mit Mock-Services in Jest.
+              <a:lnSpc>
+                <a:spcPts val="1500"/>
+              </a:lnSpc>
+              <a:spcAft>
+                <a:spcPts val="800"/>
+              </a:spcAft>
+              <a:buNone/>
+            </a:pPr>
+            <a:r>
+              <a:rPr lang="en-US" sz="1050" dirty="0">
+                <a:solidFill>
+                  <a:srgbClr val="1E293B"/>
+                </a:solidFill>
+                <a:latin typeface="Segoe UI" pitchFamily="34" charset="0"/>
+                <a:ea typeface="Segoe UI" pitchFamily="34" charset="-122"/>
+                <a:cs typeface="Segoe UI" pitchFamily="34" charset="-120"/>
+              </a:rPr>
+              <a:t>• Entity Framework Core 6.0 mit SQL Server
 </a:t>
             </a:r>
             <a:pPr indent="0" marL="0">
-              <a:buNone/>
-            </a:pPr>
-            <a:r>
-              <a:rPr lang="en-US" sz="1600" dirty="0">
-                <a:solidFill>
-                  <a:srgbClr val="FFFFFF"/>
-                </a:solidFill>
-              </a:rPr>
-              <a:t>• 4 System/E2E Tests (2 pro Person): End-to-End Flows in Playwright.
+              <a:lnSpc>
+                <a:spcPts val="1500"/>
+              </a:lnSpc>
+              <a:spcAft>
+                <a:spcPts val="800"/>
+              </a:spcAft>
+              <a:buNone/>
+            </a:pPr>
+            <a:r>
+              <a:rPr lang="en-US" sz="1050" dirty="0">
+                <a:solidFill>
+                  <a:srgbClr val="1E293B"/>
+                </a:solidFill>
+                <a:latin typeface="Segoe UI" pitchFamily="34" charset="0"/>
+                <a:ea typeface="Segoe UI" pitchFamily="34" charset="-122"/>
+                <a:cs typeface="Segoe UI" pitchFamily="34" charset="-120"/>
+              </a:rPr>
+              <a:t>• SignalR für Echtzeit-Kommunikation &amp; Notifikationen
 </a:t>
             </a:r>
             <a:pPr indent="0" marL="0">
-              <a:buNone/>
-            </a:pPr>
-            <a:r>
-              <a:rPr lang="en-US" sz="1600" dirty="0">
-                <a:solidFill>
-                  <a:srgbClr val="FFFFFF"/>
-                </a:solidFill>
-              </a:rPr>
-              <a:t>• 2 Load Tests (1 pro Person): API-Lasttests in k6.
+              <a:lnSpc>
+                <a:spcPts val="1500"/>
+              </a:lnSpc>
+              <a:spcAft>
+                <a:spcPts val="800"/>
+              </a:spcAft>
+              <a:buNone/>
+            </a:pPr>
+            <a:r>
+              <a:rPr lang="en-US" sz="1050" dirty="0">
+                <a:solidFill>
+                  <a:srgbClr val="1E293B"/>
+                </a:solidFill>
+                <a:latin typeface="Segoe UI" pitchFamily="34" charset="0"/>
+                <a:ea typeface="Segoe UI" pitchFamily="34" charset="-122"/>
+                <a:cs typeface="Segoe UI" pitchFamily="34" charset="-120"/>
+              </a:rPr>
+              <a:t>• AutoMapper für sauberes DTO-Objektmapping
 </a:t>
             </a:r>
-            <a:endParaRPr lang="en-US" sz="2200" dirty="0"/>
+            <a:pPr indent="0" marL="0">
+              <a:lnSpc>
+                <a:spcPts val="1500"/>
+              </a:lnSpc>
+              <a:buNone/>
+            </a:pPr>
+            <a:r>
+              <a:rPr lang="en-US" sz="1050" dirty="0">
+                <a:solidFill>
+                  <a:srgbClr val="1E293B"/>
+                </a:solidFill>
+                <a:latin typeface="Segoe UI" pitchFamily="34" charset="0"/>
+                <a:ea typeface="Segoe UI" pitchFamily="34" charset="-122"/>
+                <a:cs typeface="Segoe UI" pitchFamily="34" charset="-120"/>
+              </a:rPr>
+              <a:t>• Repository-Muster (Unit of Work) zur Kapselung</a:t>
+            </a:r>
+            <a:endParaRPr lang="en-US" sz="1050" dirty="0"/>
           </a:p>
         </p:txBody>
       </p:sp>
@@ -1660,7 +2054,7 @@
     <p:bg>
       <p:bgPr>
         <a:solidFill>
-          <a:srgbClr val="1E293B"/>
+          <a:srgbClr val="F8FAFC"/>
         </a:solidFill>
       </p:bgPr>
     </p:bg>
@@ -1686,8 +2080,8 @@
         </p:nvSpPr>
         <p:spPr>
           <a:xfrm>
-            <a:off x="914400" y="548640"/>
-            <a:ext cx="10332720" cy="914400"/>
+            <a:off x="731520" y="365760"/>
+            <a:ext cx="7680960" cy="365760"/>
           </a:xfrm>
           <a:prstGeom prst="rect">
             <a:avLst/>
@@ -1703,30 +2097,75 @@
               <a:buNone/>
             </a:pPr>
             <a:r>
-              <a:rPr lang="en-US" sz="3200" b="1" dirty="0">
-                <a:solidFill>
-                  <a:srgbClr val="14B8A6"/>
-                </a:solidFill>
-                <a:latin typeface="Arial" pitchFamily="34" charset="0"/>
-                <a:ea typeface="Arial" pitchFamily="34" charset="-122"/>
-                <a:cs typeface="Arial" pitchFamily="34" charset="-120"/>
-              </a:rPr>
-              <a:t>Unit &amp; Integration Testing mit JEST</a:t>
-            </a:r>
-            <a:endParaRPr lang="en-US" sz="3200" dirty="0"/>
-          </a:p>
-        </p:txBody>
-      </p:sp>
-      <p:sp>
-        <p:nvSpPr>
-          <p:cNvPr id="3" name="Text 1"/>
-          <p:cNvSpPr/>
-          <p:nvPr/>
-        </p:nvSpPr>
-        <p:spPr>
-          <a:xfrm>
-            <a:off x="914400" y="1645920"/>
-            <a:ext cx="10332720" cy="4572000"/>
+              <a:rPr lang="en-US" sz="2000" b="1" dirty="0">
+                <a:solidFill>
+                  <a:srgbClr val="1E293B"/>
+                </a:solidFill>
+                <a:latin typeface="Segoe UI" pitchFamily="34" charset="0"/>
+                <a:ea typeface="Segoe UI" pitchFamily="34" charset="-122"/>
+                <a:cs typeface="Segoe UI" pitchFamily="34" charset="-120"/>
+              </a:rPr>
+              <a:t>Testpyramide &amp; Aufgabenverteilung</a:t>
+            </a:r>
+            <a:endParaRPr lang="en-US" sz="2000" dirty="0"/>
+          </a:p>
+        </p:txBody>
+      </p:sp>
+      <p:sp>
+        <p:nvSpPr>
+          <p:cNvPr id="3" name="Shape 1"/>
+          <p:cNvSpPr/>
+          <p:nvPr/>
+        </p:nvSpPr>
+        <p:spPr>
+          <a:xfrm>
+            <a:off x="731520" y="822960"/>
+            <a:ext cx="7680960" cy="18288"/>
+          </a:xfrm>
+          <a:prstGeom prst="rect">
+            <a:avLst/>
+          </a:prstGeom>
+          <a:solidFill>
+            <a:srgbClr val="3B82F6"/>
+          </a:solidFill>
+          <a:ln/>
+        </p:spPr>
+      </p:sp>
+      <p:sp>
+        <p:nvSpPr>
+          <p:cNvPr id="4" name="Shape 2"/>
+          <p:cNvSpPr/>
+          <p:nvPr/>
+        </p:nvSpPr>
+        <p:spPr>
+          <a:xfrm>
+            <a:off x="731520" y="1097280"/>
+            <a:ext cx="3657600" cy="1280160"/>
+          </a:xfrm>
+          <a:prstGeom prst="rect">
+            <a:avLst/>
+          </a:prstGeom>
+          <a:solidFill>
+            <a:srgbClr val="FFFFFF"/>
+          </a:solidFill>
+          <a:ln w="12700">
+            <a:solidFill>
+              <a:srgbClr val="E2E8F0"/>
+            </a:solidFill>
+            <a:prstDash val="solid"/>
+          </a:ln>
+        </p:spPr>
+      </p:sp>
+      <p:sp>
+        <p:nvSpPr>
+          <p:cNvPr id="5" name="Text 3"/>
+          <p:cNvSpPr/>
+          <p:nvPr/>
+        </p:nvSpPr>
+        <p:spPr>
+          <a:xfrm>
+            <a:off x="868680" y="1188720"/>
+            <a:ext cx="3383280" cy="228600"/>
           </a:xfrm>
           <a:prstGeom prst="rect">
             <a:avLst/>
@@ -1742,87 +2181,516 @@
               <a:buNone/>
             </a:pPr>
             <a:r>
-              <a:rPr lang="en-US" sz="2200" b="1" dirty="0">
-                <a:solidFill>
-                  <a:srgbClr val="14B8A6"/>
-                </a:solidFill>
-              </a:rPr>
-              <a:t>Entfernung von Karma / Jasmine
-</a:t>
-            </a:r>
-            <a:pPr indent="0" marL="0">
-              <a:buNone/>
-            </a:pPr>
-            <a:r>
-              <a:rPr lang="en-US" sz="1600" dirty="0">
-                <a:solidFill>
-                  <a:srgbClr val="FFFFFF"/>
-                </a:solidFill>
-              </a:rPr>
-              <a:t>• Karma benötigt echte Browser-Instanzen (langsam, instabil im CI/CD).
-</a:t>
-            </a:r>
-            <a:pPr indent="0" marL="0">
-              <a:buNone/>
-            </a:pPr>
-            <a:r>
-              <a:rPr lang="en-US" sz="1600" dirty="0">
-                <a:solidFill>
-                  <a:srgbClr val="FFFFFF"/>
-                </a:solidFill>
-              </a:rPr>
-              <a:t>• Jasmine wurde durch Jest ersetzt, um modernste Assertion-Features zu nutzen.
-</a:t>
-            </a:r>
-            <a:pPr indent="0" marL="0">
-              <a:buNone/>
-            </a:pPr>
-            <a:r>
-              <a:rPr lang="en-US" sz="2200" b="1" dirty="0">
-                <a:solidFill>
-                  <a:srgbClr val="F97316"/>
-                </a:solidFill>
-              </a:rPr>
-              <a:t>Migration auf Jest &amp; jsdom
-</a:t>
-            </a:r>
-            <a:pPr indent="0" marL="0">
-              <a:buNone/>
-            </a:pPr>
-            <a:r>
-              <a:rPr lang="en-US" sz="1600" dirty="0">
-                <a:solidFill>
-                  <a:srgbClr val="FFFFFF"/>
-                </a:solidFill>
-              </a:rPr>
-              <a:t>• Tests laufen direkt in Node.js unter Verwendung einer virtuellen DOM-Umgebung (jsdom).
-</a:t>
-            </a:r>
-            <a:pPr indent="0" marL="0">
-              <a:buNone/>
-            </a:pPr>
-            <a:r>
-              <a:rPr lang="en-US" sz="1600" dirty="0">
-                <a:solidFill>
-                  <a:srgbClr val="FFFFFF"/>
-                </a:solidFill>
-              </a:rPr>
-              <a:t>• Ergebnis: Extrem schnelle Testausführungszeiten (&lt; 11 Sekunden für alle 16 Tests).
-</a:t>
-            </a:r>
-            <a:pPr indent="0" marL="0">
-              <a:buNone/>
-            </a:pPr>
-            <a:r>
-              <a:rPr lang="en-US" sz="1600" dirty="0">
-                <a:solidFill>
-                  <a:srgbClr val="FFFFFF"/>
-                </a:solidFill>
-              </a:rPr>
-              <a:t>• Verwendung von TestBed.overrideComponent, um lokale PrimeNG-Elemente &amp; MessageService sauber zu mocken.
-</a:t>
-            </a:r>
-            <a:endParaRPr lang="en-US" sz="2200" dirty="0"/>
+              <a:rPr lang="en-US" sz="1150" b="1" dirty="0">
+                <a:solidFill>
+                  <a:srgbClr val="1E3A8A"/>
+                </a:solidFill>
+                <a:latin typeface="Segoe UI" pitchFamily="34" charset="0"/>
+                <a:ea typeface="Segoe UI" pitchFamily="34" charset="-122"/>
+                <a:cs typeface="Segoe UI" pitchFamily="34" charset="-120"/>
+              </a:rPr>
+              <a:t>Unit Tests (10 Gesamt / 5 pro Person)</a:t>
+            </a:r>
+            <a:endParaRPr lang="en-US" sz="1150" dirty="0"/>
+          </a:p>
+        </p:txBody>
+      </p:sp>
+      <p:sp>
+        <p:nvSpPr>
+          <p:cNvPr id="6" name="Text 4"/>
+          <p:cNvSpPr/>
+          <p:nvPr/>
+        </p:nvSpPr>
+        <p:spPr>
+          <a:xfrm>
+            <a:off x="868680" y="1463040"/>
+            <a:ext cx="3383280" cy="822960"/>
+          </a:xfrm>
+          <a:prstGeom prst="rect">
+            <a:avLst/>
+          </a:prstGeom>
+          <a:noFill/>
+          <a:ln/>
+        </p:spPr>
+        <p:txBody>
+          <a:bodyPr wrap="square" rtlCol="0" anchor="ctr"/>
+          <a:lstStyle/>
+          <a:p>
+            <a:pPr indent="0" marL="0">
+              <a:lnSpc>
+                <a:spcPts val="1400"/>
+              </a:lnSpc>
+              <a:buNone/>
+            </a:pPr>
+            <a:r>
+              <a:rPr lang="en-US" sz="950" dirty="0">
+                <a:solidFill>
+                  <a:srgbClr val="1E293B"/>
+                </a:solidFill>
+                <a:latin typeface="Segoe UI" pitchFamily="34" charset="0"/>
+                <a:ea typeface="Segoe UI" pitchFamily="34" charset="-122"/>
+                <a:cs typeface="Segoe UI" pitchFamily="34" charset="-120"/>
+              </a:rPr>
+              <a:t>• Isolation &amp; Test der Angular Services mit Jest-Mocks</a:t>
+            </a:r>
+            <a:endParaRPr lang="en-US" sz="950" dirty="0"/>
+          </a:p>
+          <a:p>
+            <a:pPr indent="0" marL="0">
+              <a:lnSpc>
+                <a:spcPts val="1400"/>
+              </a:lnSpc>
+              <a:buNone/>
+            </a:pPr>
+            <a:r>
+              <a:rPr lang="en-US" sz="950" dirty="0">
+                <a:solidFill>
+                  <a:srgbClr val="1E293B"/>
+                </a:solidFill>
+                <a:latin typeface="Segoe UI" pitchFamily="34" charset="0"/>
+                <a:ea typeface="Segoe UI" pitchFamily="34" charset="-122"/>
+                <a:cs typeface="Segoe UI" pitchFamily="34" charset="-120"/>
+              </a:rPr>
+              <a:t>• Mocken aller HTTP-Verbindungen per MockProvider</a:t>
+            </a:r>
+            <a:endParaRPr lang="en-US" sz="950" dirty="0"/>
+          </a:p>
+        </p:txBody>
+      </p:sp>
+      <p:sp>
+        <p:nvSpPr>
+          <p:cNvPr id="7" name="Shape 5"/>
+          <p:cNvSpPr/>
+          <p:nvPr/>
+        </p:nvSpPr>
+        <p:spPr>
+          <a:xfrm>
+            <a:off x="4754880" y="1097280"/>
+            <a:ext cx="3657600" cy="1280160"/>
+          </a:xfrm>
+          <a:prstGeom prst="rect">
+            <a:avLst/>
+          </a:prstGeom>
+          <a:solidFill>
+            <a:srgbClr val="FFFFFF"/>
+          </a:solidFill>
+          <a:ln w="12700">
+            <a:solidFill>
+              <a:srgbClr val="E2E8F0"/>
+            </a:solidFill>
+            <a:prstDash val="solid"/>
+          </a:ln>
+        </p:spPr>
+      </p:sp>
+      <p:sp>
+        <p:nvSpPr>
+          <p:cNvPr id="8" name="Text 6"/>
+          <p:cNvSpPr/>
+          <p:nvPr/>
+        </p:nvSpPr>
+        <p:spPr>
+          <a:xfrm>
+            <a:off x="4892040" y="1188720"/>
+            <a:ext cx="3383280" cy="228600"/>
+          </a:xfrm>
+          <a:prstGeom prst="rect">
+            <a:avLst/>
+          </a:prstGeom>
+          <a:noFill/>
+          <a:ln/>
+        </p:spPr>
+        <p:txBody>
+          <a:bodyPr wrap="square" rtlCol="0" anchor="ctr"/>
+          <a:lstStyle/>
+          <a:p>
+            <a:pPr indent="0" marL="0">
+              <a:buNone/>
+            </a:pPr>
+            <a:r>
+              <a:rPr lang="en-US" sz="1150" b="1" dirty="0">
+                <a:solidFill>
+                  <a:srgbClr val="1E3A8A"/>
+                </a:solidFill>
+                <a:latin typeface="Segoe UI" pitchFamily="34" charset="0"/>
+                <a:ea typeface="Segoe UI" pitchFamily="34" charset="-122"/>
+                <a:cs typeface="Segoe UI" pitchFamily="34" charset="-120"/>
+              </a:rPr>
+              <a:t>Integration Tests (6 Gesamt / 3 pro Person)</a:t>
+            </a:r>
+            <a:endParaRPr lang="en-US" sz="1150" dirty="0"/>
+          </a:p>
+        </p:txBody>
+      </p:sp>
+      <p:sp>
+        <p:nvSpPr>
+          <p:cNvPr id="9" name="Text 7"/>
+          <p:cNvSpPr/>
+          <p:nvPr/>
+        </p:nvSpPr>
+        <p:spPr>
+          <a:xfrm>
+            <a:off x="4892040" y="1463040"/>
+            <a:ext cx="3383280" cy="822960"/>
+          </a:xfrm>
+          <a:prstGeom prst="rect">
+            <a:avLst/>
+          </a:prstGeom>
+          <a:noFill/>
+          <a:ln/>
+        </p:spPr>
+        <p:txBody>
+          <a:bodyPr wrap="square" rtlCol="0" anchor="ctr"/>
+          <a:lstStyle/>
+          <a:p>
+            <a:pPr indent="0" marL="0">
+              <a:lnSpc>
+                <a:spcPts val="1400"/>
+              </a:lnSpc>
+              <a:buNone/>
+            </a:pPr>
+            <a:r>
+              <a:rPr lang="en-US" sz="950" dirty="0">
+                <a:solidFill>
+                  <a:srgbClr val="1E293B"/>
+                </a:solidFill>
+                <a:latin typeface="Segoe UI" pitchFamily="34" charset="0"/>
+                <a:ea typeface="Segoe UI" pitchFamily="34" charset="-122"/>
+                <a:cs typeface="Segoe UI" pitchFamily="34" charset="-120"/>
+              </a:rPr>
+              <a:t>• Testen der UI-Komponenten (DOM-Interaktionen) in Jest</a:t>
+            </a:r>
+            <a:endParaRPr lang="en-US" sz="950" dirty="0"/>
+          </a:p>
+          <a:p>
+            <a:pPr indent="0" marL="0">
+              <a:lnSpc>
+                <a:spcPts val="1400"/>
+              </a:lnSpc>
+              <a:buNone/>
+            </a:pPr>
+            <a:r>
+              <a:rPr lang="en-US" sz="950" dirty="0">
+                <a:solidFill>
+                  <a:srgbClr val="1E293B"/>
+                </a:solidFill>
+                <a:latin typeface="Segoe UI" pitchFamily="34" charset="0"/>
+                <a:ea typeface="Segoe UI" pitchFamily="34" charset="-122"/>
+                <a:cs typeface="Segoe UI" pitchFamily="34" charset="-120"/>
+              </a:rPr>
+              <a:t>• Verwendung isolierter Mock-Services anstelle echter APIs</a:t>
+            </a:r>
+            <a:endParaRPr lang="en-US" sz="950" dirty="0"/>
+          </a:p>
+        </p:txBody>
+      </p:sp>
+      <p:sp>
+        <p:nvSpPr>
+          <p:cNvPr id="10" name="Shape 8"/>
+          <p:cNvSpPr/>
+          <p:nvPr/>
+        </p:nvSpPr>
+        <p:spPr>
+          <a:xfrm>
+            <a:off x="731520" y="2560320"/>
+            <a:ext cx="3657600" cy="1280160"/>
+          </a:xfrm>
+          <a:prstGeom prst="rect">
+            <a:avLst/>
+          </a:prstGeom>
+          <a:solidFill>
+            <a:srgbClr val="FFFFFF"/>
+          </a:solidFill>
+          <a:ln w="12700">
+            <a:solidFill>
+              <a:srgbClr val="E2E8F0"/>
+            </a:solidFill>
+            <a:prstDash val="solid"/>
+          </a:ln>
+        </p:spPr>
+      </p:sp>
+      <p:sp>
+        <p:nvSpPr>
+          <p:cNvPr id="11" name="Text 9"/>
+          <p:cNvSpPr/>
+          <p:nvPr/>
+        </p:nvSpPr>
+        <p:spPr>
+          <a:xfrm>
+            <a:off x="868680" y="2651760"/>
+            <a:ext cx="3383280" cy="228600"/>
+          </a:xfrm>
+          <a:prstGeom prst="rect">
+            <a:avLst/>
+          </a:prstGeom>
+          <a:noFill/>
+          <a:ln/>
+        </p:spPr>
+        <p:txBody>
+          <a:bodyPr wrap="square" rtlCol="0" anchor="ctr"/>
+          <a:lstStyle/>
+          <a:p>
+            <a:pPr indent="0" marL="0">
+              <a:buNone/>
+            </a:pPr>
+            <a:r>
+              <a:rPr lang="en-US" sz="1150" b="1" dirty="0">
+                <a:solidFill>
+                  <a:srgbClr val="1E3A8A"/>
+                </a:solidFill>
+                <a:latin typeface="Segoe UI" pitchFamily="34" charset="0"/>
+                <a:ea typeface="Segoe UI" pitchFamily="34" charset="-122"/>
+                <a:cs typeface="Segoe UI" pitchFamily="34" charset="-120"/>
+              </a:rPr>
+              <a:t>System / E2E Tests (4 Gesamt / 2 pro Person)</a:t>
+            </a:r>
+            <a:endParaRPr lang="en-US" sz="1150" dirty="0"/>
+          </a:p>
+        </p:txBody>
+      </p:sp>
+      <p:sp>
+        <p:nvSpPr>
+          <p:cNvPr id="12" name="Text 10"/>
+          <p:cNvSpPr/>
+          <p:nvPr/>
+        </p:nvSpPr>
+        <p:spPr>
+          <a:xfrm>
+            <a:off x="868680" y="2926080"/>
+            <a:ext cx="3383280" cy="822960"/>
+          </a:xfrm>
+          <a:prstGeom prst="rect">
+            <a:avLst/>
+          </a:prstGeom>
+          <a:noFill/>
+          <a:ln/>
+        </p:spPr>
+        <p:txBody>
+          <a:bodyPr wrap="square" rtlCol="0" anchor="ctr"/>
+          <a:lstStyle/>
+          <a:p>
+            <a:pPr indent="0" marL="0">
+              <a:lnSpc>
+                <a:spcPts val="1400"/>
+              </a:lnSpc>
+              <a:buNone/>
+            </a:pPr>
+            <a:r>
+              <a:rPr lang="en-US" sz="950" dirty="0">
+                <a:solidFill>
+                  <a:srgbClr val="1E293B"/>
+                </a:solidFill>
+                <a:latin typeface="Segoe UI" pitchFamily="34" charset="0"/>
+                <a:ea typeface="Segoe UI" pitchFamily="34" charset="-122"/>
+                <a:cs typeface="Segoe UI" pitchFamily="34" charset="-120"/>
+              </a:rPr>
+              <a:t>• Playwright-Benutzerszenarien in echten Webbrowsern</a:t>
+            </a:r>
+            <a:endParaRPr lang="en-US" sz="950" dirty="0"/>
+          </a:p>
+          <a:p>
+            <a:pPr indent="0" marL="0">
+              <a:lnSpc>
+                <a:spcPts val="1400"/>
+              </a:lnSpc>
+              <a:buNone/>
+            </a:pPr>
+            <a:r>
+              <a:rPr lang="en-US" sz="950" dirty="0">
+                <a:solidFill>
+                  <a:srgbClr val="1E293B"/>
+                </a:solidFill>
+                <a:latin typeface="Segoe UI" pitchFamily="34" charset="0"/>
+                <a:ea typeface="Segoe UI" pitchFamily="34" charset="-122"/>
+                <a:cs typeface="Segoe UI" pitchFamily="34" charset="-120"/>
+              </a:rPr>
+              <a:t>• API-Requests werden über page.route() mit Mocks simuliert</a:t>
+            </a:r>
+            <a:endParaRPr lang="en-US" sz="950" dirty="0"/>
+          </a:p>
+        </p:txBody>
+      </p:sp>
+      <p:sp>
+        <p:nvSpPr>
+          <p:cNvPr id="13" name="Shape 11"/>
+          <p:cNvSpPr/>
+          <p:nvPr/>
+        </p:nvSpPr>
+        <p:spPr>
+          <a:xfrm>
+            <a:off x="4754880" y="2560320"/>
+            <a:ext cx="3657600" cy="1280160"/>
+          </a:xfrm>
+          <a:prstGeom prst="rect">
+            <a:avLst/>
+          </a:prstGeom>
+          <a:solidFill>
+            <a:srgbClr val="FFFFFF"/>
+          </a:solidFill>
+          <a:ln w="12700">
+            <a:solidFill>
+              <a:srgbClr val="E2E8F0"/>
+            </a:solidFill>
+            <a:prstDash val="solid"/>
+          </a:ln>
+        </p:spPr>
+      </p:sp>
+      <p:sp>
+        <p:nvSpPr>
+          <p:cNvPr id="14" name="Text 12"/>
+          <p:cNvSpPr/>
+          <p:nvPr/>
+        </p:nvSpPr>
+        <p:spPr>
+          <a:xfrm>
+            <a:off x="4892040" y="2651760"/>
+            <a:ext cx="3383280" cy="228600"/>
+          </a:xfrm>
+          <a:prstGeom prst="rect">
+            <a:avLst/>
+          </a:prstGeom>
+          <a:noFill/>
+          <a:ln/>
+        </p:spPr>
+        <p:txBody>
+          <a:bodyPr wrap="square" rtlCol="0" anchor="ctr"/>
+          <a:lstStyle/>
+          <a:p>
+            <a:pPr indent="0" marL="0">
+              <a:buNone/>
+            </a:pPr>
+            <a:r>
+              <a:rPr lang="en-US" sz="1150" b="1" dirty="0">
+                <a:solidFill>
+                  <a:srgbClr val="1E3A8A"/>
+                </a:solidFill>
+                <a:latin typeface="Segoe UI" pitchFamily="34" charset="0"/>
+                <a:ea typeface="Segoe UI" pitchFamily="34" charset="-122"/>
+                <a:cs typeface="Segoe UI" pitchFamily="34" charset="-120"/>
+              </a:rPr>
+              <a:t>Lasttests (2 Gesamt / 1 pro Person)</a:t>
+            </a:r>
+            <a:endParaRPr lang="en-US" sz="1150" dirty="0"/>
+          </a:p>
+        </p:txBody>
+      </p:sp>
+      <p:sp>
+        <p:nvSpPr>
+          <p:cNvPr id="15" name="Text 13"/>
+          <p:cNvSpPr/>
+          <p:nvPr/>
+        </p:nvSpPr>
+        <p:spPr>
+          <a:xfrm>
+            <a:off x="4892040" y="2926080"/>
+            <a:ext cx="3383280" cy="822960"/>
+          </a:xfrm>
+          <a:prstGeom prst="rect">
+            <a:avLst/>
+          </a:prstGeom>
+          <a:noFill/>
+          <a:ln/>
+        </p:spPr>
+        <p:txBody>
+          <a:bodyPr wrap="square" rtlCol="0" anchor="ctr"/>
+          <a:lstStyle/>
+          <a:p>
+            <a:pPr indent="0" marL="0">
+              <a:lnSpc>
+                <a:spcPts val="1400"/>
+              </a:lnSpc>
+              <a:buNone/>
+            </a:pPr>
+            <a:r>
+              <a:rPr lang="en-US" sz="950" dirty="0">
+                <a:solidFill>
+                  <a:srgbClr val="1E293B"/>
+                </a:solidFill>
+                <a:latin typeface="Segoe UI" pitchFamily="34" charset="0"/>
+                <a:ea typeface="Segoe UI" pitchFamily="34" charset="-122"/>
+                <a:cs typeface="Segoe UI" pitchFamily="34" charset="-120"/>
+              </a:rPr>
+              <a:t>• Lokale Performance- und Spike-Messungen mit k6</a:t>
+            </a:r>
+            <a:endParaRPr lang="en-US" sz="950" dirty="0"/>
+          </a:p>
+          <a:p>
+            <a:pPr indent="0" marL="0">
+              <a:lnSpc>
+                <a:spcPts val="1400"/>
+              </a:lnSpc>
+              <a:buNone/>
+            </a:pPr>
+            <a:r>
+              <a:rPr lang="en-US" sz="950" dirty="0">
+                <a:solidFill>
+                  <a:srgbClr val="1E293B"/>
+                </a:solidFill>
+                <a:latin typeface="Segoe UI" pitchFamily="34" charset="0"/>
+                <a:ea typeface="Segoe UI" pitchFamily="34" charset="-122"/>
+                <a:cs typeface="Segoe UI" pitchFamily="34" charset="-120"/>
+              </a:rPr>
+              <a:t>• Validierung der Durchsatzgrenzen und API-Thresholds</a:t>
+            </a:r>
+            <a:endParaRPr lang="en-US" sz="950" dirty="0"/>
+          </a:p>
+        </p:txBody>
+      </p:sp>
+      <p:sp>
+        <p:nvSpPr>
+          <p:cNvPr id="16" name="Shape 14"/>
+          <p:cNvSpPr/>
+          <p:nvPr/>
+        </p:nvSpPr>
+        <p:spPr>
+          <a:xfrm>
+            <a:off x="731520" y="4023360"/>
+            <a:ext cx="7680960" cy="457200"/>
+          </a:xfrm>
+          <a:prstGeom prst="rect">
+            <a:avLst/>
+          </a:prstGeom>
+          <a:solidFill>
+            <a:srgbClr val="0F172A"/>
+          </a:solidFill>
+          <a:ln/>
+        </p:spPr>
+      </p:sp>
+      <p:sp>
+        <p:nvSpPr>
+          <p:cNvPr id="17" name="Text 15"/>
+          <p:cNvSpPr/>
+          <p:nvPr/>
+        </p:nvSpPr>
+        <p:spPr>
+          <a:xfrm>
+            <a:off x="731520" y="4023360"/>
+            <a:ext cx="7680960" cy="457200"/>
+          </a:xfrm>
+          <a:prstGeom prst="rect">
+            <a:avLst/>
+          </a:prstGeom>
+          <a:noFill/>
+          <a:ln/>
+        </p:spPr>
+        <p:txBody>
+          <a:bodyPr wrap="square" rtlCol="0" anchor="ctr"/>
+          <a:lstStyle/>
+          <a:p>
+            <a:pPr algn="ctr" indent="0" marL="0">
+              <a:buNone/>
+            </a:pPr>
+            <a:r>
+              <a:rPr lang="en-US" sz="1100" b="1" dirty="0">
+                <a:solidFill>
+                  <a:srgbClr val="10B981"/>
+                </a:solidFill>
+                <a:latin typeface="Segoe UI" pitchFamily="34" charset="0"/>
+                <a:ea typeface="Segoe UI" pitchFamily="34" charset="-122"/>
+                <a:cs typeface="Segoe UI" pitchFamily="34" charset="-120"/>
+              </a:rPr>
+              <a:t>✓ Jeder Entwickler deckt genau 11 Tests ab (Gesamtzahl: 22 Tests)</a:t>
+            </a:r>
+            <a:endParaRPr lang="en-US" sz="1100" dirty="0"/>
           </a:p>
         </p:txBody>
       </p:sp>
@@ -1840,7 +2708,7 @@
     <p:bg>
       <p:bgPr>
         <a:solidFill>
-          <a:srgbClr val="1E293B"/>
+          <a:srgbClr val="F8FAFC"/>
         </a:solidFill>
       </p:bgPr>
     </p:bg>
@@ -1866,8 +2734,8 @@
         </p:nvSpPr>
         <p:spPr>
           <a:xfrm>
-            <a:off x="914400" y="548640"/>
-            <a:ext cx="10332720" cy="914400"/>
+            <a:off x="731520" y="365760"/>
+            <a:ext cx="7680960" cy="365760"/>
           </a:xfrm>
           <a:prstGeom prst="rect">
             <a:avLst/>
@@ -1883,30 +2751,75 @@
               <a:buNone/>
             </a:pPr>
             <a:r>
-              <a:rPr lang="en-US" sz="3200" b="1" dirty="0">
-                <a:solidFill>
-                  <a:srgbClr val="14B8A6"/>
-                </a:solidFill>
-                <a:latin typeface="Arial" pitchFamily="34" charset="0"/>
-                <a:ea typeface="Arial" pitchFamily="34" charset="-122"/>
-                <a:cs typeface="Arial" pitchFamily="34" charset="-120"/>
-              </a:rPr>
-              <a:t>System &amp; E2E Testing mit Playwright</a:t>
-            </a:r>
-            <a:endParaRPr lang="en-US" sz="3200" dirty="0"/>
-          </a:p>
-        </p:txBody>
-      </p:sp>
-      <p:sp>
-        <p:nvSpPr>
-          <p:cNvPr id="3" name="Text 1"/>
-          <p:cNvSpPr/>
-          <p:nvPr/>
-        </p:nvSpPr>
-        <p:spPr>
-          <a:xfrm>
-            <a:off x="914400" y="1645920"/>
-            <a:ext cx="10332720" cy="4572000"/>
+              <a:rPr lang="en-US" sz="2000" b="1" dirty="0">
+                <a:solidFill>
+                  <a:srgbClr val="1E293B"/>
+                </a:solidFill>
+                <a:latin typeface="Segoe UI" pitchFamily="34" charset="0"/>
+                <a:ea typeface="Segoe UI" pitchFamily="34" charset="-122"/>
+                <a:cs typeface="Segoe UI" pitchFamily="34" charset="-120"/>
+              </a:rPr>
+              <a:t>Modernisiertes Test-Setup</a:t>
+            </a:r>
+            <a:endParaRPr lang="en-US" sz="2000" dirty="0"/>
+          </a:p>
+        </p:txBody>
+      </p:sp>
+      <p:sp>
+        <p:nvSpPr>
+          <p:cNvPr id="3" name="Shape 1"/>
+          <p:cNvSpPr/>
+          <p:nvPr/>
+        </p:nvSpPr>
+        <p:spPr>
+          <a:xfrm>
+            <a:off x="731520" y="822960"/>
+            <a:ext cx="7680960" cy="18288"/>
+          </a:xfrm>
+          <a:prstGeom prst="rect">
+            <a:avLst/>
+          </a:prstGeom>
+          <a:solidFill>
+            <a:srgbClr val="3B82F6"/>
+          </a:solidFill>
+          <a:ln/>
+        </p:spPr>
+      </p:sp>
+      <p:sp>
+        <p:nvSpPr>
+          <p:cNvPr id="4" name="Shape 2"/>
+          <p:cNvSpPr/>
+          <p:nvPr/>
+        </p:nvSpPr>
+        <p:spPr>
+          <a:xfrm>
+            <a:off x="731520" y="1097280"/>
+            <a:ext cx="2441448" cy="3474720"/>
+          </a:xfrm>
+          <a:prstGeom prst="rect">
+            <a:avLst/>
+          </a:prstGeom>
+          <a:solidFill>
+            <a:srgbClr val="FFFFFF"/>
+          </a:solidFill>
+          <a:ln w="12700">
+            <a:solidFill>
+              <a:srgbClr val="E2E8F0"/>
+            </a:solidFill>
+            <a:prstDash val="solid"/>
+          </a:ln>
+        </p:spPr>
+      </p:sp>
+      <p:sp>
+        <p:nvSpPr>
+          <p:cNvPr id="5" name="Text 3"/>
+          <p:cNvSpPr/>
+          <p:nvPr/>
+        </p:nvSpPr>
+        <p:spPr>
+          <a:xfrm>
+            <a:off x="868680" y="1280160"/>
+            <a:ext cx="2167128" cy="274320"/>
           </a:xfrm>
           <a:prstGeom prst="rect">
             <a:avLst/>
@@ -1922,87 +2835,397 @@
               <a:buNone/>
             </a:pPr>
             <a:r>
-              <a:rPr lang="en-US" sz="2200" b="1" dirty="0">
-                <a:solidFill>
-                  <a:srgbClr val="14B8A6"/>
-                </a:solidFill>
-              </a:rPr>
-              <a:t>Warum Playwright?
+              <a:rPr lang="en-US" sz="1300" b="1" dirty="0">
+                <a:solidFill>
+                  <a:srgbClr val="1E3A8A"/>
+                </a:solidFill>
+                <a:latin typeface="Segoe UI" pitchFamily="34" charset="0"/>
+                <a:ea typeface="Segoe UI" pitchFamily="34" charset="-122"/>
+                <a:cs typeface="Segoe UI" pitchFamily="34" charset="-120"/>
+              </a:rPr>
+              <a:t>1. Jest Migration</a:t>
+            </a:r>
+            <a:endParaRPr lang="en-US" sz="1300" dirty="0"/>
+          </a:p>
+        </p:txBody>
+      </p:sp>
+      <p:sp>
+        <p:nvSpPr>
+          <p:cNvPr id="6" name="Text 4"/>
+          <p:cNvSpPr/>
+          <p:nvPr/>
+        </p:nvSpPr>
+        <p:spPr>
+          <a:xfrm>
+            <a:off x="868680" y="1645920"/>
+            <a:ext cx="2167128" cy="2743200"/>
+          </a:xfrm>
+          <a:prstGeom prst="rect">
+            <a:avLst/>
+          </a:prstGeom>
+          <a:noFill/>
+          <a:ln/>
+        </p:spPr>
+        <p:txBody>
+          <a:bodyPr wrap="square" rtlCol="0" anchor="ctr"/>
+          <a:lstStyle/>
+          <a:p>
+            <a:pPr indent="0" marL="0">
+              <a:lnSpc>
+                <a:spcPts val="1400"/>
+              </a:lnSpc>
+              <a:spcAft>
+                <a:spcPts val="800"/>
+              </a:spcAft>
+              <a:buNone/>
+            </a:pPr>
+            <a:r>
+              <a:rPr lang="en-US" sz="950" dirty="0">
+                <a:solidFill>
+                  <a:srgbClr val="1E293B"/>
+                </a:solidFill>
+                <a:latin typeface="Segoe UI" pitchFamily="34" charset="0"/>
+                <a:ea typeface="Segoe UI" pitchFamily="34" charset="-122"/>
+                <a:cs typeface="Segoe UI" pitchFamily="34" charset="-120"/>
+              </a:rPr>
+              <a:t>• Karma/Jasmine vollständig aus Angular entfernt.
 </a:t>
             </a:r>
             <a:pPr indent="0" marL="0">
-              <a:buNone/>
-            </a:pPr>
-            <a:r>
-              <a:rPr lang="en-US" sz="1600" dirty="0">
-                <a:solidFill>
-                  <a:srgbClr val="FFFFFF"/>
-                </a:solidFill>
-              </a:rPr>
-              <a:t>• Auto-Waiting: Reduziert "flaky" Tests, da automatisch auf UI-Elemente gewartet wird.
+              <a:lnSpc>
+                <a:spcPts val="1400"/>
+              </a:lnSpc>
+              <a:spcAft>
+                <a:spcPts val="800"/>
+              </a:spcAft>
+              <a:buNone/>
+            </a:pPr>
+            <a:r>
+              <a:rPr lang="en-US" sz="950" dirty="0">
+                <a:solidFill>
+                  <a:srgbClr val="1E293B"/>
+                </a:solidFill>
+                <a:latin typeface="Segoe UI" pitchFamily="34" charset="0"/>
+                <a:ea typeface="Segoe UI" pitchFamily="34" charset="-122"/>
+                <a:cs typeface="Segoe UI" pitchFamily="34" charset="-120"/>
+              </a:rPr>
+              <a:t>• Testläufe nativ in Node.js unter Verwendung eines schnellen jsdom (virtuelles DOM).
 </a:t>
             </a:r>
             <a:pPr indent="0" marL="0">
-              <a:buNone/>
-            </a:pPr>
-            <a:r>
-              <a:rPr lang="en-US" sz="1600" dirty="0">
-                <a:solidFill>
-                  <a:srgbClr val="FFFFFF"/>
-                </a:solidFill>
-              </a:rPr>
-              <a:t>• Volle Isolation: Jeder Test startet mit einem frischen Browser-Kontext.
+              <a:lnSpc>
+                <a:spcPts val="1400"/>
+              </a:lnSpc>
+              <a:buNone/>
+            </a:pPr>
+            <a:r>
+              <a:rPr lang="en-US" sz="950" dirty="0">
+                <a:solidFill>
+                  <a:srgbClr val="1E293B"/>
+                </a:solidFill>
+                <a:latin typeface="Segoe UI" pitchFamily="34" charset="0"/>
+                <a:ea typeface="Segoe UI" pitchFamily="34" charset="-122"/>
+                <a:cs typeface="Segoe UI" pitchFamily="34" charset="-120"/>
+              </a:rPr>
+              <a:t>• Signifikante Reduktion der lokalen CI-Ausführungszeit.</a:t>
+            </a:r>
+            <a:endParaRPr lang="en-US" sz="950" dirty="0"/>
+          </a:p>
+        </p:txBody>
+      </p:sp>
+      <p:sp>
+        <p:nvSpPr>
+          <p:cNvPr id="7" name="Shape 5"/>
+          <p:cNvSpPr/>
+          <p:nvPr/>
+        </p:nvSpPr>
+        <p:spPr>
+          <a:xfrm>
+            <a:off x="3355848" y="1097280"/>
+            <a:ext cx="2432304" cy="3474720"/>
+          </a:xfrm>
+          <a:prstGeom prst="rect">
+            <a:avLst/>
+          </a:prstGeom>
+          <a:solidFill>
+            <a:srgbClr val="FFFFFF"/>
+          </a:solidFill>
+          <a:ln w="12700">
+            <a:solidFill>
+              <a:srgbClr val="E2E8F0"/>
+            </a:solidFill>
+            <a:prstDash val="solid"/>
+          </a:ln>
+        </p:spPr>
+      </p:sp>
+      <p:sp>
+        <p:nvSpPr>
+          <p:cNvPr id="8" name="Text 6"/>
+          <p:cNvSpPr/>
+          <p:nvPr/>
+        </p:nvSpPr>
+        <p:spPr>
+          <a:xfrm>
+            <a:off x="3493008" y="1280160"/>
+            <a:ext cx="2157984" cy="274320"/>
+          </a:xfrm>
+          <a:prstGeom prst="rect">
+            <a:avLst/>
+          </a:prstGeom>
+          <a:noFill/>
+          <a:ln/>
+        </p:spPr>
+        <p:txBody>
+          <a:bodyPr wrap="square" rtlCol="0" anchor="ctr"/>
+          <a:lstStyle/>
+          <a:p>
+            <a:pPr indent="0" marL="0">
+              <a:buNone/>
+            </a:pPr>
+            <a:r>
+              <a:rPr lang="en-US" sz="1300" b="1" dirty="0">
+                <a:solidFill>
+                  <a:srgbClr val="1E3A8A"/>
+                </a:solidFill>
+                <a:latin typeface="Segoe UI" pitchFamily="34" charset="0"/>
+                <a:ea typeface="Segoe UI" pitchFamily="34" charset="-122"/>
+                <a:cs typeface="Segoe UI" pitchFamily="34" charset="-120"/>
+              </a:rPr>
+              <a:t>2. Playwright E2E</a:t>
+            </a:r>
+            <a:endParaRPr lang="en-US" sz="1300" dirty="0"/>
+          </a:p>
+        </p:txBody>
+      </p:sp>
+      <p:sp>
+        <p:nvSpPr>
+          <p:cNvPr id="9" name="Text 7"/>
+          <p:cNvSpPr/>
+          <p:nvPr/>
+        </p:nvSpPr>
+        <p:spPr>
+          <a:xfrm>
+            <a:off x="3493008" y="1645920"/>
+            <a:ext cx="2157984" cy="2743200"/>
+          </a:xfrm>
+          <a:prstGeom prst="rect">
+            <a:avLst/>
+          </a:prstGeom>
+          <a:noFill/>
+          <a:ln/>
+        </p:spPr>
+        <p:txBody>
+          <a:bodyPr wrap="square" rtlCol="0" anchor="ctr"/>
+          <a:lstStyle/>
+          <a:p>
+            <a:pPr indent="0" marL="0">
+              <a:lnSpc>
+                <a:spcPts val="1400"/>
+              </a:lnSpc>
+              <a:spcAft>
+                <a:spcPts val="800"/>
+              </a:spcAft>
+              <a:buNone/>
+            </a:pPr>
+            <a:r>
+              <a:rPr lang="en-US" sz="950" dirty="0">
+                <a:solidFill>
+                  <a:srgbClr val="1E293B"/>
+                </a:solidFill>
+                <a:latin typeface="Segoe UI" pitchFamily="34" charset="0"/>
+                <a:ea typeface="Segoe UI" pitchFamily="34" charset="-122"/>
+                <a:cs typeface="Segoe UI" pitchFamily="34" charset="-120"/>
+              </a:rPr>
+              <a:t>• Führt E2E-Tests in echten Browsern (Chromium/Firefox/Webkit) aus.
 </a:t>
             </a:r>
             <a:pPr indent="0" marL="0">
-              <a:buNone/>
-            </a:pPr>
-            <a:r>
-              <a:rPr lang="en-US" sz="2200" b="1" dirty="0">
-                <a:solidFill>
-                  <a:srgbClr val="F97316"/>
-                </a:solidFill>
-              </a:rPr>
-              <a:t>API Route Interception (Test Isolation)
+              <a:lnSpc>
+                <a:spcPts val="1400"/>
+              </a:lnSpc>
+              <a:spcAft>
+                <a:spcPts val="800"/>
+              </a:spcAft>
+              <a:buNone/>
+            </a:pPr>
+            <a:r>
+              <a:rPr lang="en-US" sz="950" dirty="0">
+                <a:solidFill>
+                  <a:srgbClr val="1E293B"/>
+                </a:solidFill>
+                <a:latin typeface="Segoe UI" pitchFamily="34" charset="0"/>
+                <a:ea typeface="Segoe UI" pitchFamily="34" charset="-122"/>
+                <a:cs typeface="Segoe UI" pitchFamily="34" charset="-120"/>
+              </a:rPr>
+              <a:t>• Auto-waiting verringert instabile Testläufe ("Flakiness").
 </a:t>
             </a:r>
             <a:pPr indent="0" marL="0">
-              <a:buNone/>
-            </a:pPr>
-            <a:r>
-              <a:rPr lang="en-US" sz="1600" dirty="0">
-                <a:solidFill>
-                  <a:srgbClr val="FFFFFF"/>
-                </a:solidFill>
-              </a:rPr>
-              <a:t>• Keine Abhängigkeit von einer aktiven Testdatenbank im E2E-Lauf.
+              <a:lnSpc>
+                <a:spcPts val="1400"/>
+              </a:lnSpc>
+              <a:buNone/>
+            </a:pPr>
+            <a:r>
+              <a:rPr lang="en-US" sz="950" dirty="0">
+                <a:solidFill>
+                  <a:srgbClr val="1E293B"/>
+                </a:solidFill>
+                <a:latin typeface="Segoe UI" pitchFamily="34" charset="0"/>
+                <a:ea typeface="Segoe UI" pitchFamily="34" charset="-122"/>
+                <a:cs typeface="Segoe UI" pitchFamily="34" charset="-120"/>
+              </a:rPr>
+              <a:t>• Vollständig isolierte Kontexte pro Browserinstanz.</a:t>
+            </a:r>
+            <a:endParaRPr lang="en-US" sz="950" dirty="0"/>
+          </a:p>
+        </p:txBody>
+      </p:sp>
+      <p:sp>
+        <p:nvSpPr>
+          <p:cNvPr id="10" name="Shape 8"/>
+          <p:cNvSpPr/>
+          <p:nvPr/>
+        </p:nvSpPr>
+        <p:spPr>
+          <a:xfrm>
+            <a:off x="5971032" y="1097280"/>
+            <a:ext cx="2441448" cy="3474720"/>
+          </a:xfrm>
+          <a:prstGeom prst="rect">
+            <a:avLst/>
+          </a:prstGeom>
+          <a:solidFill>
+            <a:srgbClr val="FFFFFF"/>
+          </a:solidFill>
+          <a:ln w="12700">
+            <a:solidFill>
+              <a:srgbClr val="E2E8F0"/>
+            </a:solidFill>
+            <a:prstDash val="solid"/>
+          </a:ln>
+        </p:spPr>
+      </p:sp>
+      <p:sp>
+        <p:nvSpPr>
+          <p:cNvPr id="11" name="Text 9"/>
+          <p:cNvSpPr/>
+          <p:nvPr/>
+        </p:nvSpPr>
+        <p:spPr>
+          <a:xfrm>
+            <a:off x="6108192" y="1280160"/>
+            <a:ext cx="2167128" cy="274320"/>
+          </a:xfrm>
+          <a:prstGeom prst="rect">
+            <a:avLst/>
+          </a:prstGeom>
+          <a:noFill/>
+          <a:ln/>
+        </p:spPr>
+        <p:txBody>
+          <a:bodyPr wrap="square" rtlCol="0" anchor="ctr"/>
+          <a:lstStyle/>
+          <a:p>
+            <a:pPr indent="0" marL="0">
+              <a:buNone/>
+            </a:pPr>
+            <a:r>
+              <a:rPr lang="en-US" sz="1300" b="1" dirty="0">
+                <a:solidFill>
+                  <a:srgbClr val="1E3A8A"/>
+                </a:solidFill>
+                <a:latin typeface="Segoe UI" pitchFamily="34" charset="0"/>
+                <a:ea typeface="Segoe UI" pitchFamily="34" charset="-122"/>
+                <a:cs typeface="Segoe UI" pitchFamily="34" charset="-120"/>
+              </a:rPr>
+              <a:t>3. k6 Lasttests</a:t>
+            </a:r>
+            <a:endParaRPr lang="en-US" sz="1300" dirty="0"/>
+          </a:p>
+        </p:txBody>
+      </p:sp>
+      <p:sp>
+        <p:nvSpPr>
+          <p:cNvPr id="12" name="Text 10"/>
+          <p:cNvSpPr/>
+          <p:nvPr/>
+        </p:nvSpPr>
+        <p:spPr>
+          <a:xfrm>
+            <a:off x="6108192" y="1645920"/>
+            <a:ext cx="2167128" cy="2743200"/>
+          </a:xfrm>
+          <a:prstGeom prst="rect">
+            <a:avLst/>
+          </a:prstGeom>
+          <a:noFill/>
+          <a:ln/>
+        </p:spPr>
+        <p:txBody>
+          <a:bodyPr wrap="square" rtlCol="0" anchor="ctr"/>
+          <a:lstStyle/>
+          <a:p>
+            <a:pPr indent="0" marL="0">
+              <a:lnSpc>
+                <a:spcPts val="1400"/>
+              </a:lnSpc>
+              <a:spcAft>
+                <a:spcPts val="800"/>
+              </a:spcAft>
+              <a:buNone/>
+            </a:pPr>
+            <a:r>
+              <a:rPr lang="en-US" sz="950" dirty="0">
+                <a:solidFill>
+                  <a:srgbClr val="1E293B"/>
+                </a:solidFill>
+                <a:latin typeface="Segoe UI" pitchFamily="34" charset="0"/>
+                <a:ea typeface="Segoe UI" pitchFamily="34" charset="-122"/>
+                <a:cs typeface="Segoe UI" pitchFamily="34" charset="-120"/>
+              </a:rPr>
+              <a:t>• Lastprofile in modernem ES6 JavaScript formulierbar.
 </a:t>
             </a:r>
             <a:pPr indent="0" marL="0">
-              <a:buNone/>
-            </a:pPr>
-            <a:r>
-              <a:rPr lang="en-US" sz="1600" dirty="0">
-                <a:solidFill>
-                  <a:srgbClr val="FFFFFF"/>
-                </a:solidFill>
-              </a:rPr>
-              <a:t>• Alle API-Calls (z.B. Login, load/insert teachers) werden über page.route() gemockt.
+              <a:lnSpc>
+                <a:spcPts val="1400"/>
+              </a:lnSpc>
+              <a:spcAft>
+                <a:spcPts val="800"/>
+              </a:spcAft>
+              <a:buNone/>
+            </a:pPr>
+            <a:r>
+              <a:rPr lang="en-US" sz="950" dirty="0">
+                <a:solidFill>
+                  <a:srgbClr val="1E293B"/>
+                </a:solidFill>
+                <a:latin typeface="Segoe UI" pitchFamily="34" charset="0"/>
+                <a:ea typeface="Segoe UI" pitchFamily="34" charset="-122"/>
+                <a:cs typeface="Segoe UI" pitchFamily="34" charset="-120"/>
+              </a:rPr>
+              <a:t>• Minimale CPU- und RAM-Last dank effizienter Go-Engine.
 </a:t>
             </a:r>
             <a:pPr indent="0" marL="0">
-              <a:buNone/>
-            </a:pPr>
-            <a:r>
-              <a:rPr lang="en-US" sz="1600" dirty="0">
-                <a:solidFill>
-                  <a:srgbClr val="FFFFFF"/>
-                </a:solidFill>
-              </a:rPr>
-              <a:t>• Testbare Flows: Login-Flow, Teacher-Grid-Darstellung, Dialog-Interaktion, Login-Fehlerbehandlung.
-</a:t>
-            </a:r>
-            <a:endParaRPr lang="en-US" sz="2200" dirty="0"/>
+              <a:lnSpc>
+                <a:spcPts val="1400"/>
+              </a:lnSpc>
+              <a:buNone/>
+            </a:pPr>
+            <a:r>
+              <a:rPr lang="en-US" sz="950" dirty="0">
+                <a:solidFill>
+                  <a:srgbClr val="1E293B"/>
+                </a:solidFill>
+                <a:latin typeface="Segoe UI" pitchFamily="34" charset="0"/>
+                <a:ea typeface="Segoe UI" pitchFamily="34" charset="-122"/>
+                <a:cs typeface="Segoe UI" pitchFamily="34" charset="-120"/>
+              </a:rPr>
+              <a:t>• Schnelle Konfiguration von Metrik-Schwellwerten (Thresholds).</a:t>
+            </a:r>
+            <a:endParaRPr lang="en-US" sz="950" dirty="0"/>
           </a:p>
         </p:txBody>
       </p:sp>
@@ -2020,7 +3243,7 @@
     <p:bg>
       <p:bgPr>
         <a:solidFill>
-          <a:srgbClr val="1E293B"/>
+          <a:srgbClr val="F8FAFC"/>
         </a:solidFill>
       </p:bgPr>
     </p:bg>
@@ -2046,8 +3269,8 @@
         </p:nvSpPr>
         <p:spPr>
           <a:xfrm>
-            <a:off x="914400" y="548640"/>
-            <a:ext cx="10332720" cy="914400"/>
+            <a:off x="731520" y="365760"/>
+            <a:ext cx="7680960" cy="365760"/>
           </a:xfrm>
           <a:prstGeom prst="rect">
             <a:avLst/>
@@ -2063,30 +3286,75 @@
               <a:buNone/>
             </a:pPr>
             <a:r>
-              <a:rPr lang="en-US" sz="3200" b="1" dirty="0">
-                <a:solidFill>
-                  <a:srgbClr val="14B8A6"/>
-                </a:solidFill>
-                <a:latin typeface="Arial" pitchFamily="34" charset="0"/>
-                <a:ea typeface="Arial" pitchFamily="34" charset="-122"/>
-                <a:cs typeface="Arial" pitchFamily="34" charset="-120"/>
-              </a:rPr>
-              <a:t>Lasttests &amp; Peak-Analyse mit k6</a:t>
-            </a:r>
-            <a:endParaRPr lang="en-US" sz="3200" dirty="0"/>
-          </a:p>
-        </p:txBody>
-      </p:sp>
-      <p:sp>
-        <p:nvSpPr>
-          <p:cNvPr id="3" name="Text 1"/>
-          <p:cNvSpPr/>
-          <p:nvPr/>
-        </p:nvSpPr>
-        <p:spPr>
-          <a:xfrm>
-            <a:off x="914400" y="1645920"/>
-            <a:ext cx="10332720" cy="4572000"/>
+              <a:rPr lang="en-US" sz="2000" b="1" dirty="0">
+                <a:solidFill>
+                  <a:srgbClr val="1E293B"/>
+                </a:solidFill>
+                <a:latin typeface="Segoe UI" pitchFamily="34" charset="0"/>
+                <a:ea typeface="Segoe UI" pitchFamily="34" charset="-122"/>
+                <a:cs typeface="Segoe UI" pitchFamily="34" charset="-120"/>
+              </a:rPr>
+              <a:t>Test-Isolation &amp; CI/CD Pipeline</a:t>
+            </a:r>
+            <a:endParaRPr lang="en-US" sz="2000" dirty="0"/>
+          </a:p>
+        </p:txBody>
+      </p:sp>
+      <p:sp>
+        <p:nvSpPr>
+          <p:cNvPr id="3" name="Shape 1"/>
+          <p:cNvSpPr/>
+          <p:nvPr/>
+        </p:nvSpPr>
+        <p:spPr>
+          <a:xfrm>
+            <a:off x="731520" y="822960"/>
+            <a:ext cx="7680960" cy="18288"/>
+          </a:xfrm>
+          <a:prstGeom prst="rect">
+            <a:avLst/>
+          </a:prstGeom>
+          <a:solidFill>
+            <a:srgbClr val="3B82F6"/>
+          </a:solidFill>
+          <a:ln/>
+        </p:spPr>
+      </p:sp>
+      <p:sp>
+        <p:nvSpPr>
+          <p:cNvPr id="4" name="Shape 2"/>
+          <p:cNvSpPr/>
+          <p:nvPr/>
+        </p:nvSpPr>
+        <p:spPr>
+          <a:xfrm>
+            <a:off x="731520" y="1097280"/>
+            <a:ext cx="3657600" cy="3474720"/>
+          </a:xfrm>
+          <a:prstGeom prst="rect">
+            <a:avLst/>
+          </a:prstGeom>
+          <a:solidFill>
+            <a:srgbClr val="FFFFFF"/>
+          </a:solidFill>
+          <a:ln w="12700">
+            <a:solidFill>
+              <a:srgbClr val="E2E8F0"/>
+            </a:solidFill>
+            <a:prstDash val="solid"/>
+          </a:ln>
+        </p:spPr>
+      </p:sp>
+      <p:sp>
+        <p:nvSpPr>
+          <p:cNvPr id="5" name="Text 3"/>
+          <p:cNvSpPr/>
+          <p:nvPr/>
+        </p:nvSpPr>
+        <p:spPr>
+          <a:xfrm>
+            <a:off x="914400" y="1280160"/>
+            <a:ext cx="3291840" cy="274320"/>
           </a:xfrm>
           <a:prstGeom prst="rect">
             <a:avLst/>
@@ -2102,75 +3370,249 @@
               <a:buNone/>
             </a:pPr>
             <a:r>
-              <a:rPr lang="en-US" sz="2000" b="1" dirty="0">
-                <a:solidFill>
-                  <a:srgbClr val="14B8A6"/>
-                </a:solidFill>
-              </a:rPr>
-              <a:t>1. Courses Load Test (Aldin Memic)
+              <a:rPr lang="en-US" sz="1400" b="1" dirty="0">
+                <a:solidFill>
+                  <a:srgbClr val="1E3A8A"/>
+                </a:solidFill>
+                <a:latin typeface="Segoe UI" pitchFamily="34" charset="0"/>
+                <a:ea typeface="Segoe UI" pitchFamily="34" charset="-122"/>
+                <a:cs typeface="Segoe UI" pitchFamily="34" charset="-120"/>
+              </a:rPr>
+              <a:t>Kapselung &amp; Mocking</a:t>
+            </a:r>
+            <a:endParaRPr lang="en-US" sz="1400" dirty="0"/>
+          </a:p>
+        </p:txBody>
+      </p:sp>
+      <p:sp>
+        <p:nvSpPr>
+          <p:cNvPr id="6" name="Text 4"/>
+          <p:cNvSpPr/>
+          <p:nvPr/>
+        </p:nvSpPr>
+        <p:spPr>
+          <a:xfrm>
+            <a:off x="914400" y="1645920"/>
+            <a:ext cx="3291840" cy="2743200"/>
+          </a:xfrm>
+          <a:prstGeom prst="rect">
+            <a:avLst/>
+          </a:prstGeom>
+          <a:noFill/>
+          <a:ln/>
+        </p:spPr>
+        <p:txBody>
+          <a:bodyPr wrap="square" rtlCol="0" anchor="ctr"/>
+          <a:lstStyle/>
+          <a:p>
+            <a:pPr indent="0" marL="0">
+              <a:lnSpc>
+                <a:spcPts val="1400"/>
+              </a:lnSpc>
+              <a:spcAft>
+                <a:spcPts val="800"/>
+              </a:spcAft>
+              <a:buNone/>
+            </a:pPr>
+            <a:r>
+              <a:rPr lang="en-US" sz="950" dirty="0">
+                <a:solidFill>
+                  <a:srgbClr val="1E293B"/>
+                </a:solidFill>
+                <a:latin typeface="Segoe UI" pitchFamily="34" charset="0"/>
+                <a:ea typeface="Segoe UI" pitchFamily="34" charset="-122"/>
+                <a:cs typeface="Segoe UI" pitchFamily="34" charset="-120"/>
+              </a:rPr>
+              <a:t>• Angular HttpClient-Mocks per HttpClientTestingModule fangen Netzwerkaufrufe ab.
 </a:t>
             </a:r>
             <a:pPr indent="0" marL="0">
-              <a:buNone/>
-            </a:pPr>
-            <a:r>
-              <a:rPr lang="en-US" sz="1600" dirty="0">
-                <a:solidFill>
-                  <a:srgbClr val="FFFFFF"/>
-                </a:solidFill>
-              </a:rPr>
-              <a:t>• Ziel: Ladekapazität des Kurse-getAll-Endpunkts bei 50 parallelen Nutzern (VUs) messen.
+              <a:lnSpc>
+                <a:spcPts val="1400"/>
+              </a:lnSpc>
+              <a:spcAft>
+                <a:spcPts val="800"/>
+              </a:spcAft>
+              <a:buNone/>
+            </a:pPr>
+            <a:r>
+              <a:rPr lang="en-US" sz="950" dirty="0">
+                <a:solidFill>
+                  <a:srgbClr val="1E293B"/>
+                </a:solidFill>
+                <a:latin typeface="Segoe UI" pitchFamily="34" charset="0"/>
+                <a:ea typeface="Segoe UI" pitchFamily="34" charset="-122"/>
+                <a:cs typeface="Segoe UI" pitchFamily="34" charset="-120"/>
+              </a:rPr>
+              <a:t>• NO_ERRORS_SCHEMA blendet unbekannte UI-Tags aus und erlaubt fokussierte Tests.
 </a:t>
             </a:r>
             <a:pPr indent="0" marL="0">
-              <a:buNone/>
-            </a:pPr>
-            <a:r>
-              <a:rPr lang="en-US" sz="1600" dirty="0">
-                <a:solidFill>
-                  <a:srgbClr val="FFFFFF"/>
-                </a:solidFill>
-              </a:rPr>
-              <a:t>• Ergebnis: Antwortzeit p95 konstant bei ca. 120 ms (Ziel: &lt; 500 ms). Fehlerrate: 0%.
+              <a:lnSpc>
+                <a:spcPts val="1400"/>
+              </a:lnSpc>
+              <a:buNone/>
+            </a:pPr>
+            <a:r>
+              <a:rPr lang="en-US" sz="950" dirty="0">
+                <a:solidFill>
+                  <a:srgbClr val="1E293B"/>
+                </a:solidFill>
+                <a:latin typeface="Segoe UI" pitchFamily="34" charset="0"/>
+                <a:ea typeface="Segoe UI" pitchFamily="34" charset="-122"/>
+                <a:cs typeface="Segoe UI" pitchFamily="34" charset="-120"/>
+              </a:rPr>
+              <a:t>• Playwright fängt API-Aufrufe mit page.route() ab und liefert statische JSON-Mocks, um unabhängig von DB-Schreibzugriffen zu bleiben.</a:t>
+            </a:r>
+            <a:endParaRPr lang="en-US" sz="950" dirty="0"/>
+          </a:p>
+        </p:txBody>
+      </p:sp>
+      <p:sp>
+        <p:nvSpPr>
+          <p:cNvPr id="7" name="Shape 5"/>
+          <p:cNvSpPr/>
+          <p:nvPr/>
+        </p:nvSpPr>
+        <p:spPr>
+          <a:xfrm>
+            <a:off x="4754880" y="1097280"/>
+            <a:ext cx="3657600" cy="3474720"/>
+          </a:xfrm>
+          <a:prstGeom prst="rect">
+            <a:avLst/>
+          </a:prstGeom>
+          <a:solidFill>
+            <a:srgbClr val="FFFFFF"/>
+          </a:solidFill>
+          <a:ln w="12700">
+            <a:solidFill>
+              <a:srgbClr val="E2E8F0"/>
+            </a:solidFill>
+            <a:prstDash val="solid"/>
+          </a:ln>
+        </p:spPr>
+      </p:sp>
+      <p:sp>
+        <p:nvSpPr>
+          <p:cNvPr id="8" name="Text 6"/>
+          <p:cNvSpPr/>
+          <p:nvPr/>
+        </p:nvSpPr>
+        <p:spPr>
+          <a:xfrm>
+            <a:off x="4937760" y="1280160"/>
+            <a:ext cx="3291840" cy="274320"/>
+          </a:xfrm>
+          <a:prstGeom prst="rect">
+            <a:avLst/>
+          </a:prstGeom>
+          <a:noFill/>
+          <a:ln/>
+        </p:spPr>
+        <p:txBody>
+          <a:bodyPr wrap="square" rtlCol="0" anchor="ctr"/>
+          <a:lstStyle/>
+          <a:p>
+            <a:pPr indent="0" marL="0">
+              <a:buNone/>
+            </a:pPr>
+            <a:r>
+              <a:rPr lang="en-US" sz="1400" b="1" dirty="0">
+                <a:solidFill>
+                  <a:srgbClr val="1E3A8A"/>
+                </a:solidFill>
+                <a:latin typeface="Segoe UI" pitchFamily="34" charset="0"/>
+                <a:ea typeface="Segoe UI" pitchFamily="34" charset="-122"/>
+                <a:cs typeface="Segoe UI" pitchFamily="34" charset="-120"/>
+              </a:rPr>
+              <a:t>GitHub Actions CI Pipeline</a:t>
+            </a:r>
+            <a:endParaRPr lang="en-US" sz="1400" dirty="0"/>
+          </a:p>
+        </p:txBody>
+      </p:sp>
+      <p:sp>
+        <p:nvSpPr>
+          <p:cNvPr id="9" name="Text 7"/>
+          <p:cNvSpPr/>
+          <p:nvPr/>
+        </p:nvSpPr>
+        <p:spPr>
+          <a:xfrm>
+            <a:off x="4937760" y="1645920"/>
+            <a:ext cx="3291840" cy="2743200"/>
+          </a:xfrm>
+          <a:prstGeom prst="rect">
+            <a:avLst/>
+          </a:prstGeom>
+          <a:noFill/>
+          <a:ln/>
+        </p:spPr>
+        <p:txBody>
+          <a:bodyPr wrap="square" rtlCol="0" anchor="ctr"/>
+          <a:lstStyle/>
+          <a:p>
+            <a:pPr indent="0" marL="0">
+              <a:lnSpc>
+                <a:spcPts val="1400"/>
+              </a:lnSpc>
+              <a:spcAft>
+                <a:spcPts val="800"/>
+              </a:spcAft>
+              <a:buNone/>
+            </a:pPr>
+            <a:r>
+              <a:rPr lang="en-US" sz="950" dirty="0">
+                <a:solidFill>
+                  <a:srgbClr val="1E293B"/>
+                </a:solidFill>
+                <a:latin typeface="Segoe UI" pitchFamily="34" charset="0"/>
+                <a:ea typeface="Segoe UI" pitchFamily="34" charset="-122"/>
+                <a:cs typeface="Segoe UI" pitchFamily="34" charset="-120"/>
+              </a:rPr>
+              <a:t>• Automatische Ausführung der Unit-, Integrations- und Playwright-Tests bei Push &amp; PR.
 </a:t>
             </a:r>
             <a:pPr indent="0" marL="0">
-              <a:buNone/>
-            </a:pPr>
-            <a:r>
-              <a:rPr lang="en-US" sz="2000" b="1" dirty="0">
-                <a:solidFill>
-                  <a:srgbClr val="F97316"/>
-                </a:solidFill>
-              </a:rPr>
-              <a:t>2. Exam Spike Test (Ljundrim Ganiji)
+              <a:lnSpc>
+                <a:spcPts val="1400"/>
+              </a:lnSpc>
+              <a:spcAft>
+                <a:spcPts val="800"/>
+              </a:spcAft>
+              <a:buNone/>
+            </a:pPr>
+            <a:r>
+              <a:rPr lang="en-US" sz="950" dirty="0">
+                <a:solidFill>
+                  <a:srgbClr val="1E293B"/>
+                </a:solidFill>
+                <a:latin typeface="Segoe UI" pitchFamily="34" charset="0"/>
+                <a:ea typeface="Segoe UI" pitchFamily="34" charset="-122"/>
+                <a:cs typeface="Segoe UI" pitchFamily="34" charset="-120"/>
+              </a:rPr>
+              <a:t>• Playwright-webServer startet den Angular-Server automatisch im Hintergrund und beendet ihn nach Testende.
 </a:t>
             </a:r>
             <a:pPr indent="0" marL="0">
-              <a:buNone/>
-            </a:pPr>
-            <a:r>
-              <a:rPr lang="en-US" sz="1600" dirty="0">
-                <a:solidFill>
-                  <a:srgbClr val="FFFFFF"/>
-                </a:solidFill>
-              </a:rPr>
-              <a:t>• Ziel: Simulation eines plötzlichen Ansturms (Spike) auf submitAnswers mit 200 parallelen VUs.
-</a:t>
-            </a:r>
-            <a:pPr indent="0" marL="0">
-              <a:buNone/>
-            </a:pPr>
-            <a:r>
-              <a:rPr lang="en-US" sz="1600" dirty="0">
-                <a:solidFill>
-                  <a:srgbClr val="FFFFFF"/>
-                </a:solidFill>
-              </a:rPr>
-              <a:t>• Ergebnis: Peak-Antwortzeit p95 stieg kurzzeitig auf 780 ms, sank aber sofort wieder. Fehlerrate: 0%.
-</a:t>
-            </a:r>
-            <a:endParaRPr lang="en-US" sz="2000" dirty="0"/>
+              <a:lnSpc>
+                <a:spcPts val="1400"/>
+              </a:lnSpc>
+              <a:buNone/>
+            </a:pPr>
+            <a:r>
+              <a:rPr lang="en-US" sz="950" dirty="0">
+                <a:solidFill>
+                  <a:srgbClr val="1E293B"/>
+                </a:solidFill>
+                <a:latin typeface="Segoe UI" pitchFamily="34" charset="0"/>
+                <a:ea typeface="Segoe UI" pitchFamily="34" charset="-122"/>
+                <a:cs typeface="Segoe UI" pitchFamily="34" charset="-120"/>
+              </a:rPr>
+              <a:t>• Fehlerhafte Tests blockieren den Merge-Vorgang und sichern eine robuste Codebasis.</a:t>
+            </a:r>
+            <a:endParaRPr lang="en-US" sz="950" dirty="0"/>
           </a:p>
         </p:txBody>
       </p:sp>
@@ -2188,7 +3630,7 @@
     <p:bg>
       <p:bgPr>
         <a:solidFill>
-          <a:srgbClr val="1E293B"/>
+          <a:srgbClr val="F8FAFC"/>
         </a:solidFill>
       </p:bgPr>
     </p:bg>
@@ -2214,8 +3656,8 @@
         </p:nvSpPr>
         <p:spPr>
           <a:xfrm>
-            <a:off x="914400" y="2011680"/>
-            <a:ext cx="10332720" cy="914400"/>
+            <a:off x="731520" y="365760"/>
+            <a:ext cx="7680960" cy="365760"/>
           </a:xfrm>
           <a:prstGeom prst="rect">
             <a:avLst/>
@@ -2231,30 +3673,75 @@
               <a:buNone/>
             </a:pPr>
             <a:r>
-              <a:rPr lang="en-US" sz="4000" b="1" dirty="0">
-                <a:solidFill>
-                  <a:srgbClr val="14B8A6"/>
-                </a:solidFill>
-                <a:latin typeface="Arial" pitchFamily="34" charset="0"/>
-                <a:ea typeface="Arial" pitchFamily="34" charset="-122"/>
-                <a:cs typeface="Arial" pitchFamily="34" charset="-120"/>
-              </a:rPr>
-              <a:t>Vielen Dank für Ihre Aufmerksamkeit!</a:t>
-            </a:r>
-            <a:endParaRPr lang="en-US" sz="4000" dirty="0"/>
-          </a:p>
-        </p:txBody>
-      </p:sp>
-      <p:sp>
-        <p:nvSpPr>
-          <p:cNvPr id="3" name="Text 1"/>
-          <p:cNvSpPr/>
-          <p:nvPr/>
-        </p:nvSpPr>
-        <p:spPr>
-          <a:xfrm>
-            <a:off x="914400" y="2926080"/>
-            <a:ext cx="10332720" cy="731520"/>
+              <a:rPr lang="en-US" sz="2000" b="1" dirty="0">
+                <a:solidFill>
+                  <a:srgbClr val="1E293B"/>
+                </a:solidFill>
+                <a:latin typeface="Segoe UI" pitchFamily="34" charset="0"/>
+                <a:ea typeface="Segoe UI" pitchFamily="34" charset="-122"/>
+                <a:cs typeface="Segoe UI" pitchFamily="34" charset="-120"/>
+              </a:rPr>
+              <a:t>Last- &amp; Spike-Tests (k6 Analysis)</a:t>
+            </a:r>
+            <a:endParaRPr lang="en-US" sz="2000" dirty="0"/>
+          </a:p>
+        </p:txBody>
+      </p:sp>
+      <p:sp>
+        <p:nvSpPr>
+          <p:cNvPr id="3" name="Shape 1"/>
+          <p:cNvSpPr/>
+          <p:nvPr/>
+        </p:nvSpPr>
+        <p:spPr>
+          <a:xfrm>
+            <a:off x="731520" y="822960"/>
+            <a:ext cx="7680960" cy="18288"/>
+          </a:xfrm>
+          <a:prstGeom prst="rect">
+            <a:avLst/>
+          </a:prstGeom>
+          <a:solidFill>
+            <a:srgbClr val="3B82F6"/>
+          </a:solidFill>
+          <a:ln/>
+        </p:spPr>
+      </p:sp>
+      <p:sp>
+        <p:nvSpPr>
+          <p:cNvPr id="4" name="Shape 2"/>
+          <p:cNvSpPr/>
+          <p:nvPr/>
+        </p:nvSpPr>
+        <p:spPr>
+          <a:xfrm>
+            <a:off x="731520" y="1097280"/>
+            <a:ext cx="3657600" cy="3474720"/>
+          </a:xfrm>
+          <a:prstGeom prst="rect">
+            <a:avLst/>
+          </a:prstGeom>
+          <a:solidFill>
+            <a:srgbClr val="FFFFFF"/>
+          </a:solidFill>
+          <a:ln w="12700">
+            <a:solidFill>
+              <a:srgbClr val="E2E8F0"/>
+            </a:solidFill>
+            <a:prstDash val="solid"/>
+          </a:ln>
+        </p:spPr>
+      </p:sp>
+      <p:sp>
+        <p:nvSpPr>
+          <p:cNvPr id="5" name="Text 3"/>
+          <p:cNvSpPr/>
+          <p:nvPr/>
+        </p:nvSpPr>
+        <p:spPr>
+          <a:xfrm>
+            <a:off x="914400" y="1280160"/>
+            <a:ext cx="3291840" cy="274320"/>
           </a:xfrm>
           <a:prstGeom prst="rect">
             <a:avLst/>
@@ -2270,30 +3757,30 @@
               <a:buNone/>
             </a:pPr>
             <a:r>
-              <a:rPr lang="en-US" sz="2400" dirty="0">
-                <a:solidFill>
-                  <a:srgbClr val="FFFFFF"/>
-                </a:solidFill>
-                <a:latin typeface="Arial" pitchFamily="34" charset="0"/>
-                <a:ea typeface="Arial" pitchFamily="34" charset="-122"/>
-                <a:cs typeface="Arial" pitchFamily="34" charset="-120"/>
-              </a:rPr>
-              <a:t>Fragen &amp; Diskussion zum Testsetup</a:t>
-            </a:r>
-            <a:endParaRPr lang="en-US" sz="2400" dirty="0"/>
-          </a:p>
-        </p:txBody>
-      </p:sp>
-      <p:sp>
-        <p:nvSpPr>
-          <p:cNvPr id="4" name="Text 2"/>
-          <p:cNvSpPr/>
-          <p:nvPr/>
-        </p:nvSpPr>
-        <p:spPr>
-          <a:xfrm>
-            <a:off x="914400" y="3840480"/>
-            <a:ext cx="10332720" cy="1371600"/>
+              <a:rPr lang="en-US" sz="1300" b="1" dirty="0">
+                <a:solidFill>
+                  <a:srgbClr val="1E3A8A"/>
+                </a:solidFill>
+                <a:latin typeface="Segoe UI" pitchFamily="34" charset="0"/>
+                <a:ea typeface="Segoe UI" pitchFamily="34" charset="-122"/>
+                <a:cs typeface="Segoe UI" pitchFamily="34" charset="-120"/>
+              </a:rPr>
+              <a:t>1. Courses Load Test (Aldin Memic)</a:t>
+            </a:r>
+            <a:endParaRPr lang="en-US" sz="1300" dirty="0"/>
+          </a:p>
+        </p:txBody>
+      </p:sp>
+      <p:sp>
+        <p:nvSpPr>
+          <p:cNvPr id="6" name="Text 4"/>
+          <p:cNvSpPr/>
+          <p:nvPr/>
+        </p:nvSpPr>
+        <p:spPr>
+          <a:xfrm>
+            <a:off x="914400" y="1645920"/>
+            <a:ext cx="3291840" cy="2743200"/>
           </a:xfrm>
           <a:prstGeom prst="rect">
             <a:avLst/>
@@ -2306,37 +3793,480 @@
           <a:lstStyle/>
           <a:p>
             <a:pPr indent="0" marL="0">
-              <a:buNone/>
-            </a:pPr>
-            <a:r>
-              <a:rPr lang="en-US" sz="1800" dirty="0">
-                <a:solidFill>
-                  <a:srgbClr val="F1F5F9"/>
-                </a:solidFill>
-                <a:latin typeface="Arial" pitchFamily="34" charset="0"/>
-                <a:ea typeface="Arial" pitchFamily="34" charset="-122"/>
-                <a:cs typeface="Arial" pitchFamily="34" charset="-120"/>
-              </a:rPr>
-              <a:t>• Lokale Testausführung läuft vollständig</a:t>
-            </a:r>
-            <a:endParaRPr lang="en-US" sz="1800" dirty="0"/>
-          </a:p>
-          <a:p>
-            <a:pPr indent="0" marL="0">
-              <a:buNone/>
-            </a:pPr>
-            <a:r>
-              <a:rPr lang="en-US" sz="1800" dirty="0">
-                <a:solidFill>
-                  <a:srgbClr val="F1F5F9"/>
-                </a:solidFill>
-                <a:latin typeface="Arial" pitchFamily="34" charset="0"/>
-                <a:ea typeface="Arial" pitchFamily="34" charset="-122"/>
-                <a:cs typeface="Arial" pitchFamily="34" charset="-120"/>
-              </a:rPr>
-              <a:t>• Alle 22 Tests erfolgreich implementiert und dokumentiert</a:t>
-            </a:r>
-            <a:endParaRPr lang="en-US" sz="1800" dirty="0"/>
+              <a:lnSpc>
+                <a:spcPts val="1400"/>
+              </a:lnSpc>
+              <a:spcAft>
+                <a:spcPts val="600"/>
+              </a:spcAft>
+              <a:buNone/>
+            </a:pPr>
+            <a:r>
+              <a:rPr lang="en-US" sz="950" dirty="0">
+                <a:solidFill>
+                  <a:srgbClr val="1E293B"/>
+                </a:solidFill>
+                <a:latin typeface="Segoe UI" pitchFamily="34" charset="0"/>
+                <a:ea typeface="Segoe UI" pitchFamily="34" charset="-122"/>
+                <a:cs typeface="Segoe UI" pitchFamily="34" charset="-120"/>
+              </a:rPr>
+              <a:t>• Endpoint: GET /api/course/getAll
+</a:t>
+            </a:r>
+            <a:pPr indent="0" marL="0">
+              <a:lnSpc>
+                <a:spcPts val="1400"/>
+              </a:lnSpc>
+              <a:spcAft>
+                <a:spcPts val="600"/>
+              </a:spcAft>
+              <a:buNone/>
+            </a:pPr>
+            <a:r>
+              <a:rPr lang="en-US" sz="950" dirty="0">
+                <a:solidFill>
+                  <a:srgbClr val="1E293B"/>
+                </a:solidFill>
+                <a:latin typeface="Segoe UI" pitchFamily="34" charset="0"/>
+                <a:ea typeface="Segoe UI" pitchFamily="34" charset="-122"/>
+                <a:cs typeface="Segoe UI" pitchFamily="34" charset="-120"/>
+              </a:rPr>
+              <a:t>• Profil: Linearer Anstieg auf 50 VUs (10s), danach 15s Haltephase unter Volllast, gefolgt von 5s Cool-down.
+</a:t>
+            </a:r>
+            <a:pPr indent="0" marL="0">
+              <a:lnSpc>
+                <a:spcPts val="1400"/>
+              </a:lnSpc>
+              <a:spcAft>
+                <a:spcPts val="600"/>
+              </a:spcAft>
+              <a:buNone/>
+            </a:pPr>
+            <a:r>
+              <a:rPr lang="en-US" sz="950" dirty="0">
+                <a:solidFill>
+                  <a:srgbClr val="1E293B"/>
+                </a:solidFill>
+                <a:latin typeface="Segoe UI" pitchFamily="34" charset="0"/>
+                <a:ea typeface="Segoe UI" pitchFamily="34" charset="-122"/>
+                <a:cs typeface="Segoe UI" pitchFamily="34" charset="-120"/>
+              </a:rPr>
+              <a:t>• Metrik (p95): Reaktionsgeschwindigkeit konstant bei ca. 120 ms (Threshold lag bei &lt; 500 ms).
+</a:t>
+            </a:r>
+            <a:pPr indent="0" marL="0">
+              <a:lnSpc>
+                <a:spcPts val="1400"/>
+              </a:lnSpc>
+              <a:buNone/>
+            </a:pPr>
+            <a:r>
+              <a:rPr lang="en-US" sz="950" dirty="0">
+                <a:solidFill>
+                  <a:srgbClr val="1E293B"/>
+                </a:solidFill>
+                <a:latin typeface="Segoe UI" pitchFamily="34" charset="0"/>
+                <a:ea typeface="Segoe UI" pitchFamily="34" charset="-122"/>
+                <a:cs typeface="Segoe UI" pitchFamily="34" charset="-120"/>
+              </a:rPr>
+              <a:t>• Fehlerrate: 0,00% (Alle Anfragen bestanden).</a:t>
+            </a:r>
+            <a:endParaRPr lang="en-US" sz="950" dirty="0"/>
+          </a:p>
+        </p:txBody>
+      </p:sp>
+      <p:sp>
+        <p:nvSpPr>
+          <p:cNvPr id="7" name="Shape 5"/>
+          <p:cNvSpPr/>
+          <p:nvPr/>
+        </p:nvSpPr>
+        <p:spPr>
+          <a:xfrm>
+            <a:off x="4754880" y="1097280"/>
+            <a:ext cx="3657600" cy="3474720"/>
+          </a:xfrm>
+          <a:prstGeom prst="rect">
+            <a:avLst/>
+          </a:prstGeom>
+          <a:solidFill>
+            <a:srgbClr val="FFFFFF"/>
+          </a:solidFill>
+          <a:ln w="12700">
+            <a:solidFill>
+              <a:srgbClr val="E2E8F0"/>
+            </a:solidFill>
+            <a:prstDash val="solid"/>
+          </a:ln>
+        </p:spPr>
+      </p:sp>
+      <p:sp>
+        <p:nvSpPr>
+          <p:cNvPr id="8" name="Text 6"/>
+          <p:cNvSpPr/>
+          <p:nvPr/>
+        </p:nvSpPr>
+        <p:spPr>
+          <a:xfrm>
+            <a:off x="4937760" y="1280160"/>
+            <a:ext cx="3291840" cy="274320"/>
+          </a:xfrm>
+          <a:prstGeom prst="rect">
+            <a:avLst/>
+          </a:prstGeom>
+          <a:noFill/>
+          <a:ln/>
+        </p:spPr>
+        <p:txBody>
+          <a:bodyPr wrap="square" rtlCol="0" anchor="ctr"/>
+          <a:lstStyle/>
+          <a:p>
+            <a:pPr indent="0" marL="0">
+              <a:buNone/>
+            </a:pPr>
+            <a:r>
+              <a:rPr lang="en-US" sz="1300" b="1" dirty="0">
+                <a:solidFill>
+                  <a:srgbClr val="1E3A8A"/>
+                </a:solidFill>
+                <a:latin typeface="Segoe UI" pitchFamily="34" charset="0"/>
+                <a:ea typeface="Segoe UI" pitchFamily="34" charset="-122"/>
+                <a:cs typeface="Segoe UI" pitchFamily="34" charset="-120"/>
+              </a:rPr>
+              <a:t>2. Exam Spike Test (Ljundrim Ganiji)</a:t>
+            </a:r>
+            <a:endParaRPr lang="en-US" sz="1300" dirty="0"/>
+          </a:p>
+        </p:txBody>
+      </p:sp>
+      <p:sp>
+        <p:nvSpPr>
+          <p:cNvPr id="9" name="Text 7"/>
+          <p:cNvSpPr/>
+          <p:nvPr/>
+        </p:nvSpPr>
+        <p:spPr>
+          <a:xfrm>
+            <a:off x="4937760" y="1645920"/>
+            <a:ext cx="3291840" cy="2743200"/>
+          </a:xfrm>
+          <a:prstGeom prst="rect">
+            <a:avLst/>
+          </a:prstGeom>
+          <a:noFill/>
+          <a:ln/>
+        </p:spPr>
+        <p:txBody>
+          <a:bodyPr wrap="square" rtlCol="0" anchor="ctr"/>
+          <a:lstStyle/>
+          <a:p>
+            <a:pPr indent="0" marL="0">
+              <a:lnSpc>
+                <a:spcPts val="1400"/>
+              </a:lnSpc>
+              <a:spcAft>
+                <a:spcPts val="600"/>
+              </a:spcAft>
+              <a:buNone/>
+            </a:pPr>
+            <a:r>
+              <a:rPr lang="en-US" sz="950" dirty="0">
+                <a:solidFill>
+                  <a:srgbClr val="1E293B"/>
+                </a:solidFill>
+                <a:latin typeface="Segoe UI" pitchFamily="34" charset="0"/>
+                <a:ea typeface="Segoe UI" pitchFamily="34" charset="-122"/>
+                <a:cs typeface="Segoe UI" pitchFamily="34" charset="-120"/>
+              </a:rPr>
+              <a:t>• Endpoint: POST /api/exam/submitAnswers
+</a:t>
+            </a:r>
+            <a:pPr indent="0" marL="0">
+              <a:lnSpc>
+                <a:spcPts val="1400"/>
+              </a:lnSpc>
+              <a:spcAft>
+                <a:spcPts val="600"/>
+              </a:spcAft>
+              <a:buNone/>
+            </a:pPr>
+            <a:r>
+              <a:rPr lang="en-US" sz="950" dirty="0">
+                <a:solidFill>
+                  <a:srgbClr val="1E293B"/>
+                </a:solidFill>
+                <a:latin typeface="Segoe UI" pitchFamily="34" charset="0"/>
+                <a:ea typeface="Segoe UI" pitchFamily="34" charset="-122"/>
+                <a:cs typeface="Segoe UI" pitchFamily="34" charset="-120"/>
+              </a:rPr>
+              <a:t>• Profil: Rapider Anstieg von 20 auf 200 VUs innerhalb von 5s, gefolgt von 15s dauerhafter Lastspitze.
+</a:t>
+            </a:r>
+            <a:pPr indent="0" marL="0">
+              <a:lnSpc>
+                <a:spcPts val="1400"/>
+              </a:lnSpc>
+              <a:spcAft>
+                <a:spcPts val="600"/>
+              </a:spcAft>
+              <a:buNone/>
+            </a:pPr>
+            <a:r>
+              <a:rPr lang="en-US" sz="950" dirty="0">
+                <a:solidFill>
+                  <a:srgbClr val="1E293B"/>
+                </a:solidFill>
+                <a:latin typeface="Segoe UI" pitchFamily="34" charset="0"/>
+                <a:ea typeface="Segoe UI" pitchFamily="34" charset="-122"/>
+                <a:cs typeface="Segoe UI" pitchFamily="34" charset="-120"/>
+              </a:rPr>
+              <a:t>• Metrik (p95): Antwortzeit stieg kurz auf maximal 780 ms an, sank aber schnell auf ca. 150 ms.
+</a:t>
+            </a:r>
+            <a:pPr indent="0" marL="0">
+              <a:lnSpc>
+                <a:spcPts val="1400"/>
+              </a:lnSpc>
+              <a:buNone/>
+            </a:pPr>
+            <a:r>
+              <a:rPr lang="en-US" sz="950" dirty="0">
+                <a:solidFill>
+                  <a:srgbClr val="1E293B"/>
+                </a:solidFill>
+                <a:latin typeface="Segoe UI" pitchFamily="34" charset="0"/>
+                <a:ea typeface="Segoe UI" pitchFamily="34" charset="-122"/>
+                <a:cs typeface="Segoe UI" pitchFamily="34" charset="-120"/>
+              </a:rPr>
+              <a:t>• Fehlerrate: 0,00% (Kein Verbindungsabbruch).</a:t>
+            </a:r>
+            <a:endParaRPr lang="en-US" sz="950" dirty="0"/>
+          </a:p>
+        </p:txBody>
+      </p:sp>
+    </p:spTree>
+  </p:cSld>
+  <p:clrMapOvr>
+    <a:masterClrMapping/>
+  </p:clrMapOvr>
+</p:sld>
+</file>
+
+<file path=ppt/slides/slide7.xml><?xml version="1.0" encoding="utf-8"?>
+<p:sld xmlns:a="http://schemas.openxmlformats.org/drawingml/2006/main" xmlns:r="http://schemas.openxmlformats.org/officeDocument/2006/relationships" xmlns:p="http://schemas.openxmlformats.org/presentationml/2006/main">
+  <p:cSld name="Slide 7">
+    <p:bg>
+      <p:bgPr>
+        <a:solidFill>
+          <a:srgbClr val="0F172A"/>
+        </a:solidFill>
+      </p:bgPr>
+    </p:bg>
+    <p:spTree>
+      <p:nvGrpSpPr>
+        <p:cNvPr id="1" name=""/>
+        <p:cNvGrpSpPr/>
+        <p:nvPr/>
+      </p:nvGrpSpPr>
+      <p:grpSpPr>
+        <a:xfrm>
+          <a:off x="0" y="0"/>
+          <a:ext cx="0" cy="0"/>
+          <a:chOff x="0" y="0"/>
+          <a:chExt cx="0" cy="0"/>
+        </a:xfrm>
+      </p:grpSpPr>
+      <p:sp>
+        <p:nvSpPr>
+          <p:cNvPr id="2" name="Text 0"/>
+          <p:cNvSpPr/>
+          <p:nvPr/>
+        </p:nvSpPr>
+        <p:spPr>
+          <a:xfrm>
+            <a:off x="457200" y="731520"/>
+            <a:ext cx="8229600" cy="457200"/>
+          </a:xfrm>
+          <a:prstGeom prst="rect">
+            <a:avLst/>
+          </a:prstGeom>
+          <a:noFill/>
+          <a:ln/>
+        </p:spPr>
+        <p:txBody>
+          <a:bodyPr wrap="square" rtlCol="0" anchor="ctr"/>
+          <a:lstStyle/>
+          <a:p>
+            <a:pPr algn="ctr" indent="0" marL="0">
+              <a:buNone/>
+            </a:pPr>
+            <a:r>
+              <a:rPr lang="en-US" sz="2400" b="1" dirty="0">
+                <a:solidFill>
+                  <a:srgbClr val="F8FAFC"/>
+                </a:solidFill>
+                <a:latin typeface="Segoe UI" pitchFamily="34" charset="0"/>
+                <a:ea typeface="Segoe UI" pitchFamily="34" charset="-122"/>
+                <a:cs typeface="Segoe UI" pitchFamily="34" charset="-120"/>
+              </a:rPr>
+              <a:t>Fazit &amp; Projektergebnis</a:t>
+            </a:r>
+            <a:endParaRPr lang="en-US" sz="2400" dirty="0"/>
+          </a:p>
+        </p:txBody>
+      </p:sp>
+      <p:sp>
+        <p:nvSpPr>
+          <p:cNvPr id="3" name="Shape 1"/>
+          <p:cNvSpPr/>
+          <p:nvPr/>
+        </p:nvSpPr>
+        <p:spPr>
+          <a:xfrm>
+            <a:off x="3200400" y="1280160"/>
+            <a:ext cx="2743200" cy="27432"/>
+          </a:xfrm>
+          <a:prstGeom prst="rect">
+            <a:avLst/>
+          </a:prstGeom>
+          <a:solidFill>
+            <a:srgbClr val="10B981"/>
+          </a:solidFill>
+          <a:ln/>
+        </p:spPr>
+      </p:sp>
+      <p:sp>
+        <p:nvSpPr>
+          <p:cNvPr id="4" name="Shape 2"/>
+          <p:cNvSpPr/>
+          <p:nvPr/>
+        </p:nvSpPr>
+        <p:spPr>
+          <a:xfrm>
+            <a:off x="1371600" y="1645920"/>
+            <a:ext cx="6400800" cy="2926080"/>
+          </a:xfrm>
+          <a:prstGeom prst="rect">
+            <a:avLst/>
+          </a:prstGeom>
+          <a:solidFill>
+            <a:srgbClr val="1E293B"/>
+          </a:solidFill>
+          <a:ln/>
+        </p:spPr>
+      </p:sp>
+      <p:sp>
+        <p:nvSpPr>
+          <p:cNvPr id="5" name="Text 3"/>
+          <p:cNvSpPr/>
+          <p:nvPr/>
+        </p:nvSpPr>
+        <p:spPr>
+          <a:xfrm>
+            <a:off x="1645920" y="1828800"/>
+            <a:ext cx="5852160" cy="2560320"/>
+          </a:xfrm>
+          <a:prstGeom prst="rect">
+            <a:avLst/>
+          </a:prstGeom>
+          <a:noFill/>
+          <a:ln/>
+        </p:spPr>
+        <p:txBody>
+          <a:bodyPr wrap="square" rtlCol="0" anchor="ctr"/>
+          <a:lstStyle/>
+          <a:p>
+            <a:pPr indent="0" marL="0">
+              <a:lnSpc>
+                <a:spcPts val="1600"/>
+              </a:lnSpc>
+              <a:buNone/>
+            </a:pPr>
+            <a:r>
+              <a:rPr lang="en-US" sz="1100" dirty="0">
+                <a:solidFill>
+                  <a:srgbClr val="F8FAFC"/>
+                </a:solidFill>
+                <a:latin typeface="Segoe UI" pitchFamily="34" charset="0"/>
+                <a:ea typeface="Segoe UI" pitchFamily="34" charset="-122"/>
+                <a:cs typeface="Segoe UI" pitchFamily="34" charset="-120"/>
+              </a:rPr>
+              <a:t>✓ Erfolgreiche Jest-Migration (Karma komplett abgelöst)
+</a:t>
+            </a:r>
+            <a:pPr indent="0" marL="0">
+              <a:lnSpc>
+                <a:spcPts val="1600"/>
+              </a:lnSpc>
+              <a:buNone/>
+            </a:pPr>
+            <a:r>
+              <a:rPr lang="en-US" sz="1100" dirty="0">
+                <a:solidFill>
+                  <a:srgbClr val="F8FAFC"/>
+                </a:solidFill>
+                <a:latin typeface="Segoe UI" pitchFamily="34" charset="0"/>
+                <a:ea typeface="Segoe UI" pitchFamily="34" charset="-122"/>
+                <a:cs typeface="Segoe UI" pitchFamily="34" charset="-120"/>
+              </a:rPr>
+              <a:t>✓ Hohe Absicherung: 22 Tests insgesamt (genau 11 pro Person)
+</a:t>
+            </a:r>
+            <a:pPr indent="0" marL="0">
+              <a:lnSpc>
+                <a:spcPts val="1600"/>
+              </a:lnSpc>
+              <a:buNone/>
+            </a:pPr>
+            <a:r>
+              <a:rPr lang="en-US" sz="1100" dirty="0">
+                <a:solidFill>
+                  <a:srgbClr val="F8FAFC"/>
+                </a:solidFill>
+                <a:latin typeface="Segoe UI" pitchFamily="34" charset="0"/>
+                <a:ea typeface="Segoe UI" pitchFamily="34" charset="-122"/>
+                <a:cs typeface="Segoe UI" pitchFamily="34" charset="-120"/>
+              </a:rPr>
+              <a:t>✓ Stabile Playwright E2E-Tests durch API-Netzwerk-Mocking im CI
+</a:t>
+            </a:r>
+            <a:pPr indent="0" marL="0">
+              <a:lnSpc>
+                <a:spcPts val="1600"/>
+              </a:lnSpc>
+              <a:buNone/>
+            </a:pPr>
+            <a:r>
+              <a:rPr lang="en-US" sz="1100" dirty="0">
+                <a:solidFill>
+                  <a:srgbClr val="F8FAFC"/>
+                </a:solidFill>
+                <a:latin typeface="Segoe UI" pitchFamily="34" charset="0"/>
+                <a:ea typeface="Segoe UI" pitchFamily="34" charset="-122"/>
+                <a:cs typeface="Segoe UI" pitchFamily="34" charset="-120"/>
+              </a:rPr>
+              <a:t>✓ Performance-Nachweis: k6 Lasttests belegen Stabilität der API
+</a:t>
+            </a:r>
+            <a:pPr indent="0" marL="0">
+              <a:lnSpc>
+                <a:spcPts val="1600"/>
+              </a:lnSpc>
+              <a:buNone/>
+            </a:pPr>
+            <a:r>
+              <a:rPr lang="en-US" sz="1100" dirty="0">
+                <a:solidFill>
+                  <a:srgbClr val="F8FAFC"/>
+                </a:solidFill>
+                <a:latin typeface="Segoe UI" pitchFamily="34" charset="0"/>
+                <a:ea typeface="Segoe UI" pitchFamily="34" charset="-122"/>
+                <a:cs typeface="Segoe UI" pitchFamily="34" charset="-120"/>
+              </a:rPr>
+              <a:t>✓ Vollautomatische Validierung über GitHub Actions Build-Pipeline</a:t>
+            </a:r>
+            <a:endParaRPr lang="en-US" sz="1100" dirty="0"/>
           </a:p>
         </p:txBody>
       </p:sp>

</xml_diff>

<commit_message>
finalisation of presentation, removed one point
</commit_message>
<xml_diff>
--- a/PRESENTATION.pptx
+++ b/PRESENTATION.pptx
@@ -1637,7 +1637,7 @@
         </p:nvSpPr>
         <p:spPr>
           <a:xfrm>
-            <a:off x="4937760" y="1577340"/>
+            <a:off x="4937760" y="1564278"/>
             <a:ext cx="3291840" cy="2743200"/>
           </a:xfrm>
           <a:prstGeom prst="rect">
@@ -3755,7 +3755,7 @@
 ✓ Hohe Absicherung: 22 Tests insgesamt (genau 11 pro Person)
 ✓ Stabile Playwright E2E-Tests durch API-Netzwerk-Mocking im CI
 ✓ Performance-Nachweis: k6 Lasttests belegen Stabilität der API
-✓ Vollautomatische Validierung über GitHub Actions Build-Pipeline</a:t>
+</a:t>
             </a:r>
             <a:endParaRPr lang="en-US" sz="1100" dirty="0"/>
           </a:p>

</xml_diff>